<commit_message>
Restyle UI: warm canvas, pastel KPI tiles, icon rail, docked AI assistant with orb, motion; refresh screenshots, report and deck
</commit_message>
<xml_diff>
--- a/report/Wealthline_Presentation.pptx
+++ b/report/Wealthline_Presentation.pptx
@@ -2281,7 +2281,7 @@
     <p:bg>
       <p:bgPr>
         <a:solidFill>
-          <a:srgbClr val="111827"/>
+          <a:srgbClr val="14161C"/>
         </a:solidFill>
       </p:bgPr>
     </p:bg>
@@ -2314,11 +2314,11 @@
             <a:avLst/>
           </a:prstGeom>
           <a:solidFill>
-            <a:srgbClr val="C2410C"/>
+            <a:srgbClr val="4C5CF0"/>
           </a:solidFill>
           <a:ln w="12700">
             <a:solidFill>
-              <a:srgbClr val="C2410C"/>
+              <a:srgbClr val="4C5CF0"/>
             </a:solidFill>
             <a:prstDash val="solid"/>
           </a:ln>
@@ -2390,7 +2390,7 @@
             <a:r>
               <a:rPr lang="en-US" sz="2400" dirty="0">
                 <a:solidFill>
-                  <a:srgbClr val="FFB48A"/>
+                  <a:srgbClr val="B8C0FF"/>
                 </a:solidFill>
                 <a:latin typeface="Calibri" pitchFamily="34" charset="0"/>
                 <a:ea typeface="Calibri" pitchFamily="34" charset="-122"/>
@@ -2429,7 +2429,7 @@
             <a:r>
               <a:rPr lang="en-US" sz="1400" b="1" spc="300" kern="0" dirty="0">
                 <a:solidFill>
-                  <a:srgbClr val="FF8A3D"/>
+                  <a:srgbClr val="8D98FF"/>
                 </a:solidFill>
                 <a:latin typeface="Calibri" pitchFamily="34" charset="0"/>
                 <a:ea typeface="Calibri" pitchFamily="34" charset="-122"/>
@@ -2534,7 +2534,7 @@
             <a:r>
               <a:rPr lang="en-US" sz="1600" dirty="0">
                 <a:solidFill>
-                  <a:srgbClr val="FFB48A"/>
+                  <a:srgbClr val="B8C0FF"/>
                 </a:solidFill>
                 <a:latin typeface="Consolas" pitchFamily="34" charset="0"/>
                 <a:ea typeface="Consolas" pitchFamily="34" charset="-122"/>
@@ -2639,7 +2639,7 @@
             <a:r>
               <a:rPr lang="en-US" sz="1600" dirty="0">
                 <a:solidFill>
-                  <a:srgbClr val="FFB48A"/>
+                  <a:srgbClr val="B8C0FF"/>
                 </a:solidFill>
                 <a:latin typeface="Consolas" pitchFamily="34" charset="0"/>
                 <a:ea typeface="Consolas" pitchFamily="34" charset="-122"/>
@@ -2744,7 +2744,7 @@
             <a:r>
               <a:rPr lang="en-US" sz="1600" dirty="0">
                 <a:solidFill>
-                  <a:srgbClr val="FFB48A"/>
+                  <a:srgbClr val="B8C0FF"/>
                 </a:solidFill>
                 <a:latin typeface="Consolas" pitchFamily="34" charset="0"/>
                 <a:ea typeface="Consolas" pitchFamily="34" charset="-122"/>
@@ -2849,7 +2849,7 @@
             <a:r>
               <a:rPr lang="en-US" sz="1600" dirty="0">
                 <a:solidFill>
-                  <a:srgbClr val="FFB48A"/>
+                  <a:srgbClr val="B8C0FF"/>
                 </a:solidFill>
                 <a:latin typeface="Consolas" pitchFamily="34" charset="0"/>
                 <a:ea typeface="Consolas" pitchFamily="34" charset="-122"/>
@@ -2947,11 +2947,11 @@
             <a:avLst/>
           </a:prstGeom>
           <a:solidFill>
-            <a:srgbClr val="C2410C"/>
+            <a:srgbClr val="4C5CF0"/>
           </a:solidFill>
           <a:ln w="12700">
             <a:solidFill>
-              <a:srgbClr val="C2410C"/>
+              <a:srgbClr val="4C5CF0"/>
             </a:solidFill>
             <a:prstDash val="solid"/>
           </a:ln>
@@ -2984,7 +2984,7 @@
             <a:r>
               <a:rPr lang="en-US" sz="1200" b="1" spc="200" kern="0" dirty="0">
                 <a:solidFill>
-                  <a:srgbClr val="C2410C"/>
+                  <a:srgbClr val="4C5CF0"/>
                 </a:solidFill>
                 <a:latin typeface="Calibri" pitchFamily="34" charset="0"/>
                 <a:ea typeface="Calibri" pitchFamily="34" charset="-122"/>
@@ -3023,7 +3023,7 @@
             <a:r>
               <a:rPr lang="en-US" sz="3000" b="1" dirty="0">
                 <a:solidFill>
-                  <a:srgbClr val="111827"/>
+                  <a:srgbClr val="14161C"/>
                 </a:solidFill>
                 <a:latin typeface="Calibri" pitchFamily="34" charset="0"/>
                 <a:ea typeface="Calibri" pitchFamily="34" charset="-122"/>
@@ -3204,7 +3204,7 @@
                       <a:tailEnd type="none" w="med" len="med"/>
                     </a:lnB>
                     <a:solidFill>
-                      <a:srgbClr val="111827"/>
+                      <a:srgbClr val="14161C"/>
                     </a:solidFill>
                   </a:tcPr>
                 </a:tc>
@@ -3272,7 +3272,7 @@
                       <a:tailEnd type="none" w="med" len="med"/>
                     </a:lnB>
                     <a:solidFill>
-                      <a:srgbClr val="111827"/>
+                      <a:srgbClr val="14161C"/>
                     </a:solidFill>
                   </a:tcPr>
                 </a:tc>
@@ -3289,7 +3289,7 @@
                       <a:r>
                         <a:rPr lang="en-US" sz="1500" dirty="0">
                           <a:solidFill>
-                            <a:srgbClr val="111827"/>
+                            <a:srgbClr val="14161C"/>
                           </a:solidFill>
                           <a:latin typeface="Calibri" pitchFamily="34" charset="0"/>
                           <a:ea typeface="Calibri" pitchFamily="34" charset="-122"/>
@@ -3357,7 +3357,7 @@
                       <a:r>
                         <a:rPr lang="en-US" sz="1500" dirty="0">
                           <a:solidFill>
-                            <a:srgbClr val="111827"/>
+                            <a:srgbClr val="14161C"/>
                           </a:solidFill>
                           <a:latin typeface="Calibri" pitchFamily="34" charset="0"/>
                           <a:ea typeface="Calibri" pitchFamily="34" charset="-122"/>
@@ -3427,7 +3427,7 @@
                       <a:r>
                         <a:rPr lang="en-US" sz="1500" dirty="0">
                           <a:solidFill>
-                            <a:srgbClr val="111827"/>
+                            <a:srgbClr val="14161C"/>
                           </a:solidFill>
                           <a:latin typeface="Calibri" pitchFamily="34" charset="0"/>
                           <a:ea typeface="Calibri" pitchFamily="34" charset="-122"/>
@@ -3495,7 +3495,7 @@
                       <a:r>
                         <a:rPr lang="en-US" sz="1500" dirty="0">
                           <a:solidFill>
-                            <a:srgbClr val="111827"/>
+                            <a:srgbClr val="14161C"/>
                           </a:solidFill>
                           <a:latin typeface="Calibri" pitchFamily="34" charset="0"/>
                           <a:ea typeface="Calibri" pitchFamily="34" charset="-122"/>
@@ -3565,7 +3565,7 @@
                       <a:r>
                         <a:rPr lang="en-US" sz="1500" dirty="0">
                           <a:solidFill>
-                            <a:srgbClr val="111827"/>
+                            <a:srgbClr val="14161C"/>
                           </a:solidFill>
                           <a:latin typeface="Calibri" pitchFamily="34" charset="0"/>
                           <a:ea typeface="Calibri" pitchFamily="34" charset="-122"/>
@@ -3633,7 +3633,7 @@
                       <a:r>
                         <a:rPr lang="en-US" sz="1500" dirty="0">
                           <a:solidFill>
-                            <a:srgbClr val="111827"/>
+                            <a:srgbClr val="14161C"/>
                           </a:solidFill>
                           <a:latin typeface="Calibri" pitchFamily="34" charset="0"/>
                           <a:ea typeface="Calibri" pitchFamily="34" charset="-122"/>
@@ -3703,7 +3703,7 @@
                       <a:r>
                         <a:rPr lang="en-US" sz="1500" dirty="0">
                           <a:solidFill>
-                            <a:srgbClr val="111827"/>
+                            <a:srgbClr val="14161C"/>
                           </a:solidFill>
                           <a:latin typeface="Calibri" pitchFamily="34" charset="0"/>
                           <a:ea typeface="Calibri" pitchFamily="34" charset="-122"/>
@@ -3771,7 +3771,7 @@
                       <a:r>
                         <a:rPr lang="en-US" sz="1500" dirty="0">
                           <a:solidFill>
-                            <a:srgbClr val="111827"/>
+                            <a:srgbClr val="14161C"/>
                           </a:solidFill>
                           <a:latin typeface="Calibri" pitchFamily="34" charset="0"/>
                           <a:ea typeface="Calibri" pitchFamily="34" charset="-122"/>
@@ -3841,7 +3841,7 @@
                       <a:r>
                         <a:rPr lang="en-US" sz="1500" dirty="0">
                           <a:solidFill>
-                            <a:srgbClr val="111827"/>
+                            <a:srgbClr val="14161C"/>
                           </a:solidFill>
                           <a:latin typeface="Calibri" pitchFamily="34" charset="0"/>
                           <a:ea typeface="Calibri" pitchFamily="34" charset="-122"/>
@@ -3909,7 +3909,7 @@
                       <a:r>
                         <a:rPr lang="en-US" sz="1500" dirty="0">
                           <a:solidFill>
-                            <a:srgbClr val="111827"/>
+                            <a:srgbClr val="14161C"/>
                           </a:solidFill>
                           <a:latin typeface="Calibri" pitchFamily="34" charset="0"/>
                           <a:ea typeface="Calibri" pitchFamily="34" charset="-122"/>
@@ -4057,11 +4057,11 @@
             <a:avLst/>
           </a:prstGeom>
           <a:solidFill>
-            <a:srgbClr val="C2410C"/>
+            <a:srgbClr val="4C5CF0"/>
           </a:solidFill>
           <a:ln w="12700">
             <a:solidFill>
-              <a:srgbClr val="C2410C"/>
+              <a:srgbClr val="4C5CF0"/>
             </a:solidFill>
             <a:prstDash val="solid"/>
           </a:ln>
@@ -4094,7 +4094,7 @@
             <a:r>
               <a:rPr lang="en-US" sz="1200" b="1" spc="200" kern="0" dirty="0">
                 <a:solidFill>
-                  <a:srgbClr val="C2410C"/>
+                  <a:srgbClr val="4C5CF0"/>
                 </a:solidFill>
                 <a:latin typeface="Calibri" pitchFamily="34" charset="0"/>
                 <a:ea typeface="Calibri" pitchFamily="34" charset="-122"/>
@@ -4133,7 +4133,7 @@
             <a:r>
               <a:rPr lang="en-US" sz="3000" b="1" dirty="0">
                 <a:solidFill>
-                  <a:srgbClr val="111827"/>
+                  <a:srgbClr val="14161C"/>
                 </a:solidFill>
                 <a:latin typeface="Calibri" pitchFamily="34" charset="0"/>
                 <a:ea typeface="Calibri" pitchFamily="34" charset="-122"/>
@@ -4396,11 +4396,11 @@
             <a:avLst/>
           </a:prstGeom>
           <a:solidFill>
-            <a:srgbClr val="C2410C"/>
+            <a:srgbClr val="4C5CF0"/>
           </a:solidFill>
           <a:ln w="12700">
             <a:solidFill>
-              <a:srgbClr val="C2410C"/>
+              <a:srgbClr val="4C5CF0"/>
             </a:solidFill>
             <a:prstDash val="solid"/>
           </a:ln>
@@ -4433,7 +4433,7 @@
             <a:r>
               <a:rPr lang="en-US" sz="1200" b="1" spc="200" kern="0" dirty="0">
                 <a:solidFill>
-                  <a:srgbClr val="C2410C"/>
+                  <a:srgbClr val="4C5CF0"/>
                 </a:solidFill>
                 <a:latin typeface="Calibri" pitchFamily="34" charset="0"/>
                 <a:ea typeface="Calibri" pitchFamily="34" charset="-122"/>
@@ -4472,7 +4472,7 @@
             <a:r>
               <a:rPr lang="en-US" sz="3000" b="1" dirty="0">
                 <a:solidFill>
-                  <a:srgbClr val="111827"/>
+                  <a:srgbClr val="14161C"/>
                 </a:solidFill>
                 <a:latin typeface="Calibri" pitchFamily="34" charset="0"/>
                 <a:ea typeface="Calibri" pitchFamily="34" charset="-122"/>
@@ -4798,11 +4798,11 @@
             <a:avLst/>
           </a:prstGeom>
           <a:solidFill>
-            <a:srgbClr val="C2410C"/>
+            <a:srgbClr val="4C5CF0"/>
           </a:solidFill>
           <a:ln w="12700">
             <a:solidFill>
-              <a:srgbClr val="C2410C"/>
+              <a:srgbClr val="4C5CF0"/>
             </a:solidFill>
             <a:prstDash val="solid"/>
           </a:ln>
@@ -4835,7 +4835,7 @@
             <a:r>
               <a:rPr lang="en-US" sz="1200" b="1" spc="200" kern="0" dirty="0">
                 <a:solidFill>
-                  <a:srgbClr val="C2410C"/>
+                  <a:srgbClr val="4C5CF0"/>
                 </a:solidFill>
                 <a:latin typeface="Calibri" pitchFamily="34" charset="0"/>
                 <a:ea typeface="Calibri" pitchFamily="34" charset="-122"/>
@@ -4874,7 +4874,7 @@
             <a:r>
               <a:rPr lang="en-US" sz="3000" b="1" dirty="0">
                 <a:solidFill>
-                  <a:srgbClr val="111827"/>
+                  <a:srgbClr val="14161C"/>
                 </a:solidFill>
                 <a:latin typeface="Calibri" pitchFamily="34" charset="0"/>
                 <a:ea typeface="Calibri" pitchFamily="34" charset="-122"/>
@@ -5263,11 +5263,11 @@
             <a:avLst/>
           </a:prstGeom>
           <a:solidFill>
-            <a:srgbClr val="C2410C"/>
+            <a:srgbClr val="4C5CF0"/>
           </a:solidFill>
           <a:ln w="12700">
             <a:solidFill>
-              <a:srgbClr val="C2410C"/>
+              <a:srgbClr val="4C5CF0"/>
             </a:solidFill>
             <a:prstDash val="solid"/>
           </a:ln>
@@ -5300,7 +5300,7 @@
             <a:r>
               <a:rPr lang="en-US" sz="1200" b="1" spc="200" kern="0" dirty="0">
                 <a:solidFill>
-                  <a:srgbClr val="C2410C"/>
+                  <a:srgbClr val="4C5CF0"/>
                 </a:solidFill>
                 <a:latin typeface="Calibri" pitchFamily="34" charset="0"/>
                 <a:ea typeface="Calibri" pitchFamily="34" charset="-122"/>
@@ -5339,7 +5339,7 @@
             <a:r>
               <a:rPr lang="en-US" sz="3000" b="1" dirty="0">
                 <a:solidFill>
-                  <a:srgbClr val="111827"/>
+                  <a:srgbClr val="14161C"/>
                 </a:solidFill>
                 <a:latin typeface="Calibri" pitchFamily="34" charset="0"/>
                 <a:ea typeface="Calibri" pitchFamily="34" charset="-122"/>
@@ -5446,11 +5446,11 @@
             </a:avLst>
           </a:prstGeom>
           <a:solidFill>
-            <a:srgbClr val="FFF1E8"/>
+            <a:srgbClr val="E7E9FF"/>
           </a:solidFill>
           <a:ln w="12700">
             <a:solidFill>
-              <a:srgbClr val="C2410C"/>
+              <a:srgbClr val="4C5CF0"/>
             </a:solidFill>
             <a:prstDash val="solid"/>
           </a:ln>
@@ -5483,7 +5483,7 @@
             <a:r>
               <a:rPr lang="en-US" sz="3800" b="1" dirty="0">
                 <a:solidFill>
-                  <a:srgbClr val="C2410C"/>
+                  <a:srgbClr val="4C5CF0"/>
                 </a:solidFill>
                 <a:latin typeface="Calibri" pitchFamily="34" charset="0"/>
                 <a:ea typeface="Calibri" pitchFamily="34" charset="-122"/>
@@ -5522,7 +5522,7 @@
             <a:r>
               <a:rPr lang="en-US" sz="1300" dirty="0">
                 <a:solidFill>
-                  <a:srgbClr val="111827"/>
+                  <a:srgbClr val="14161C"/>
                 </a:solidFill>
                 <a:latin typeface="Calibri" pitchFamily="34" charset="0"/>
                 <a:ea typeface="Calibri" pitchFamily="34" charset="-122"/>
@@ -5551,11 +5551,11 @@
             </a:avLst>
           </a:prstGeom>
           <a:solidFill>
-            <a:srgbClr val="FFF1E8"/>
+            <a:srgbClr val="E7E9FF"/>
           </a:solidFill>
           <a:ln w="12700">
             <a:solidFill>
-              <a:srgbClr val="C2410C"/>
+              <a:srgbClr val="4C5CF0"/>
             </a:solidFill>
             <a:prstDash val="solid"/>
           </a:ln>
@@ -5588,7 +5588,7 @@
             <a:r>
               <a:rPr lang="en-US" sz="3800" b="1" dirty="0">
                 <a:solidFill>
-                  <a:srgbClr val="C2410C"/>
+                  <a:srgbClr val="4C5CF0"/>
                 </a:solidFill>
                 <a:latin typeface="Calibri" pitchFamily="34" charset="0"/>
                 <a:ea typeface="Calibri" pitchFamily="34" charset="-122"/>
@@ -5627,7 +5627,7 @@
             <a:r>
               <a:rPr lang="en-US" sz="1300" dirty="0">
                 <a:solidFill>
-                  <a:srgbClr val="111827"/>
+                  <a:srgbClr val="14161C"/>
                 </a:solidFill>
                 <a:latin typeface="Calibri" pitchFamily="34" charset="0"/>
                 <a:ea typeface="Calibri" pitchFamily="34" charset="-122"/>
@@ -5656,11 +5656,11 @@
             </a:avLst>
           </a:prstGeom>
           <a:solidFill>
-            <a:srgbClr val="FFF1E8"/>
+            <a:srgbClr val="E7E9FF"/>
           </a:solidFill>
           <a:ln w="12700">
             <a:solidFill>
-              <a:srgbClr val="C2410C"/>
+              <a:srgbClr val="4C5CF0"/>
             </a:solidFill>
             <a:prstDash val="solid"/>
           </a:ln>
@@ -5693,7 +5693,7 @@
             <a:r>
               <a:rPr lang="en-US" sz="3800" b="1" dirty="0">
                 <a:solidFill>
-                  <a:srgbClr val="C2410C"/>
+                  <a:srgbClr val="4C5CF0"/>
                 </a:solidFill>
                 <a:latin typeface="Calibri" pitchFamily="34" charset="0"/>
                 <a:ea typeface="Calibri" pitchFamily="34" charset="-122"/>
@@ -5732,7 +5732,7 @@
             <a:r>
               <a:rPr lang="en-US" sz="1300" dirty="0">
                 <a:solidFill>
-                  <a:srgbClr val="111827"/>
+                  <a:srgbClr val="14161C"/>
                 </a:solidFill>
                 <a:latin typeface="Calibri" pitchFamily="34" charset="0"/>
                 <a:ea typeface="Calibri" pitchFamily="34" charset="-122"/>
@@ -5761,11 +5761,11 @@
             </a:avLst>
           </a:prstGeom>
           <a:solidFill>
-            <a:srgbClr val="FFF1E8"/>
+            <a:srgbClr val="E7E9FF"/>
           </a:solidFill>
           <a:ln w="12700">
             <a:solidFill>
-              <a:srgbClr val="C2410C"/>
+              <a:srgbClr val="4C5CF0"/>
             </a:solidFill>
             <a:prstDash val="solid"/>
           </a:ln>
@@ -5798,7 +5798,7 @@
             <a:r>
               <a:rPr lang="en-US" sz="3800" b="1" dirty="0">
                 <a:solidFill>
-                  <a:srgbClr val="C2410C"/>
+                  <a:srgbClr val="4C5CF0"/>
                 </a:solidFill>
                 <a:latin typeface="Calibri" pitchFamily="34" charset="0"/>
                 <a:ea typeface="Calibri" pitchFamily="34" charset="-122"/>
@@ -5837,7 +5837,7 @@
             <a:r>
               <a:rPr lang="en-US" sz="1300" dirty="0">
                 <a:solidFill>
-                  <a:srgbClr val="111827"/>
+                  <a:srgbClr val="14161C"/>
                 </a:solidFill>
                 <a:latin typeface="Calibri" pitchFamily="34" charset="0"/>
                 <a:ea typeface="Calibri" pitchFamily="34" charset="-122"/>
@@ -5941,7 +5941,7 @@
                       <a:tailEnd type="none" w="med" len="med"/>
                     </a:lnB>
                     <a:solidFill>
-                      <a:srgbClr val="111827"/>
+                      <a:srgbClr val="14161C"/>
                     </a:solidFill>
                   </a:tcPr>
                 </a:tc>
@@ -6009,7 +6009,7 @@
                       <a:tailEnd type="none" w="med" len="med"/>
                     </a:lnB>
                     <a:solidFill>
-                      <a:srgbClr val="111827"/>
+                      <a:srgbClr val="14161C"/>
                     </a:solidFill>
                   </a:tcPr>
                 </a:tc>
@@ -6077,7 +6077,7 @@
                       <a:tailEnd type="none" w="med" len="med"/>
                     </a:lnB>
                     <a:solidFill>
-                      <a:srgbClr val="111827"/>
+                      <a:srgbClr val="14161C"/>
                     </a:solidFill>
                   </a:tcPr>
                 </a:tc>
@@ -6094,7 +6094,7 @@
                       <a:r>
                         <a:rPr lang="en-US" sz="1400" dirty="0">
                           <a:solidFill>
-                            <a:srgbClr val="111827"/>
+                            <a:srgbClr val="14161C"/>
                           </a:solidFill>
                           <a:latin typeface="Calibri" pitchFamily="34" charset="0"/>
                           <a:ea typeface="Calibri" pitchFamily="34" charset="-122"/>
@@ -6162,7 +6162,7 @@
                       <a:r>
                         <a:rPr lang="en-US" sz="1400" dirty="0">
                           <a:solidFill>
-                            <a:srgbClr val="111827"/>
+                            <a:srgbClr val="14161C"/>
                           </a:solidFill>
                           <a:latin typeface="Calibri" pitchFamily="34" charset="0"/>
                           <a:ea typeface="Calibri" pitchFamily="34" charset="-122"/>
@@ -6230,7 +6230,7 @@
                       <a:r>
                         <a:rPr lang="en-US" sz="1400" dirty="0">
                           <a:solidFill>
-                            <a:srgbClr val="111827"/>
+                            <a:srgbClr val="14161C"/>
                           </a:solidFill>
                           <a:latin typeface="Calibri" pitchFamily="34" charset="0"/>
                           <a:ea typeface="Calibri" pitchFamily="34" charset="-122"/>
@@ -6300,7 +6300,7 @@
                       <a:r>
                         <a:rPr lang="en-US" sz="1400" dirty="0">
                           <a:solidFill>
-                            <a:srgbClr val="111827"/>
+                            <a:srgbClr val="14161C"/>
                           </a:solidFill>
                           <a:latin typeface="Calibri" pitchFamily="34" charset="0"/>
                           <a:ea typeface="Calibri" pitchFamily="34" charset="-122"/>
@@ -6368,7 +6368,7 @@
                       <a:r>
                         <a:rPr lang="en-US" sz="1400" dirty="0">
                           <a:solidFill>
-                            <a:srgbClr val="111827"/>
+                            <a:srgbClr val="14161C"/>
                           </a:solidFill>
                           <a:latin typeface="Calibri" pitchFamily="34" charset="0"/>
                           <a:ea typeface="Calibri" pitchFamily="34" charset="-122"/>
@@ -6436,7 +6436,7 @@
                       <a:r>
                         <a:rPr lang="en-US" sz="1400" dirty="0">
                           <a:solidFill>
-                            <a:srgbClr val="111827"/>
+                            <a:srgbClr val="14161C"/>
                           </a:solidFill>
                           <a:latin typeface="Calibri" pitchFamily="34" charset="0"/>
                           <a:ea typeface="Calibri" pitchFamily="34" charset="-122"/>
@@ -6506,7 +6506,7 @@
                       <a:r>
                         <a:rPr lang="en-US" sz="1400" dirty="0">
                           <a:solidFill>
-                            <a:srgbClr val="111827"/>
+                            <a:srgbClr val="14161C"/>
                           </a:solidFill>
                           <a:latin typeface="Calibri" pitchFamily="34" charset="0"/>
                           <a:ea typeface="Calibri" pitchFamily="34" charset="-122"/>
@@ -6574,7 +6574,7 @@
                       <a:r>
                         <a:rPr lang="en-US" sz="1400" dirty="0">
                           <a:solidFill>
-                            <a:srgbClr val="111827"/>
+                            <a:srgbClr val="14161C"/>
                           </a:solidFill>
                           <a:latin typeface="Calibri" pitchFamily="34" charset="0"/>
                           <a:ea typeface="Calibri" pitchFamily="34" charset="-122"/>
@@ -6642,7 +6642,7 @@
                       <a:r>
                         <a:rPr lang="en-US" sz="1400" dirty="0">
                           <a:solidFill>
-                            <a:srgbClr val="111827"/>
+                            <a:srgbClr val="14161C"/>
                           </a:solidFill>
                           <a:latin typeface="Calibri" pitchFamily="34" charset="0"/>
                           <a:ea typeface="Calibri" pitchFamily="34" charset="-122"/>
@@ -6712,7 +6712,7 @@
                       <a:r>
                         <a:rPr lang="en-US" sz="1400" dirty="0">
                           <a:solidFill>
-                            <a:srgbClr val="111827"/>
+                            <a:srgbClr val="14161C"/>
                           </a:solidFill>
                           <a:latin typeface="Calibri" pitchFamily="34" charset="0"/>
                           <a:ea typeface="Calibri" pitchFamily="34" charset="-122"/>
@@ -6780,7 +6780,7 @@
                       <a:r>
                         <a:rPr lang="en-US" sz="1400" dirty="0">
                           <a:solidFill>
-                            <a:srgbClr val="111827"/>
+                            <a:srgbClr val="14161C"/>
                           </a:solidFill>
                           <a:latin typeface="Calibri" pitchFamily="34" charset="0"/>
                           <a:ea typeface="Calibri" pitchFamily="34" charset="-122"/>
@@ -6848,7 +6848,7 @@
                       <a:r>
                         <a:rPr lang="en-US" sz="1400" dirty="0">
                           <a:solidFill>
-                            <a:srgbClr val="111827"/>
+                            <a:srgbClr val="14161C"/>
                           </a:solidFill>
                           <a:latin typeface="Calibri" pitchFamily="34" charset="0"/>
                           <a:ea typeface="Calibri" pitchFamily="34" charset="-122"/>
@@ -6957,11 +6957,11 @@
             <a:avLst/>
           </a:prstGeom>
           <a:solidFill>
-            <a:srgbClr val="C2410C"/>
+            <a:srgbClr val="4C5CF0"/>
           </a:solidFill>
           <a:ln w="12700">
             <a:solidFill>
-              <a:srgbClr val="C2410C"/>
+              <a:srgbClr val="4C5CF0"/>
             </a:solidFill>
             <a:prstDash val="solid"/>
           </a:ln>
@@ -6994,7 +6994,7 @@
             <a:r>
               <a:rPr lang="en-US" sz="1200" b="1" spc="200" kern="0" dirty="0">
                 <a:solidFill>
-                  <a:srgbClr val="C2410C"/>
+                  <a:srgbClr val="4C5CF0"/>
                 </a:solidFill>
                 <a:latin typeface="Calibri" pitchFamily="34" charset="0"/>
                 <a:ea typeface="Calibri" pitchFamily="34" charset="-122"/>
@@ -7033,7 +7033,7 @@
             <a:r>
               <a:rPr lang="en-US" sz="3000" b="1" dirty="0">
                 <a:solidFill>
-                  <a:srgbClr val="111827"/>
+                  <a:srgbClr val="14161C"/>
                 </a:solidFill>
                 <a:latin typeface="Calibri" pitchFamily="34" charset="0"/>
                 <a:ea typeface="Calibri" pitchFamily="34" charset="-122"/>
@@ -7198,7 +7198,7 @@
             <a:r>
               <a:rPr lang="en-US" sz="1600" b="1" dirty="0">
                 <a:solidFill>
-                  <a:srgbClr val="111827"/>
+                  <a:srgbClr val="14161C"/>
                 </a:solidFill>
                 <a:latin typeface="Calibri" pitchFamily="34" charset="0"/>
                 <a:ea typeface="Calibri" pitchFamily="34" charset="-122"/>
@@ -7257,11 +7257,11 @@
             <a:avLst/>
           </a:prstGeom>
           <a:solidFill>
-            <a:srgbClr val="C2410C"/>
+            <a:srgbClr val="4C5CF0"/>
           </a:solidFill>
           <a:ln w="12700">
             <a:solidFill>
-              <a:srgbClr val="C2410C"/>
+              <a:srgbClr val="4C5CF0"/>
             </a:solidFill>
             <a:prstDash val="solid"/>
           </a:ln>
@@ -7294,7 +7294,7 @@
             <a:r>
               <a:rPr lang="en-US" sz="1200" b="1" spc="200" kern="0" dirty="0">
                 <a:solidFill>
-                  <a:srgbClr val="C2410C"/>
+                  <a:srgbClr val="4C5CF0"/>
                 </a:solidFill>
                 <a:latin typeface="Calibri" pitchFamily="34" charset="0"/>
                 <a:ea typeface="Calibri" pitchFamily="34" charset="-122"/>
@@ -7333,7 +7333,7 @@
             <a:r>
               <a:rPr lang="en-US" sz="3000" b="1" dirty="0">
                 <a:solidFill>
-                  <a:srgbClr val="111827"/>
+                  <a:srgbClr val="14161C"/>
                 </a:solidFill>
                 <a:latin typeface="Calibri" pitchFamily="34" charset="0"/>
                 <a:ea typeface="Calibri" pitchFamily="34" charset="-122"/>
@@ -7477,7 +7477,7 @@
             <a:r>
               <a:rPr lang="en-US" sz="1700" b="1" dirty="0">
                 <a:solidFill>
-                  <a:srgbClr val="C2410C"/>
+                  <a:srgbClr val="4C5CF0"/>
                 </a:solidFill>
                 <a:latin typeface="Calibri" pitchFamily="34" charset="0"/>
                 <a:ea typeface="Calibri" pitchFamily="34" charset="-122"/>
@@ -7516,7 +7516,7 @@
             <a:r>
               <a:rPr lang="en-US" sz="1400" dirty="0">
                 <a:solidFill>
-                  <a:srgbClr val="111827"/>
+                  <a:srgbClr val="14161C"/>
                 </a:solidFill>
                 <a:latin typeface="Calibri" pitchFamily="34" charset="0"/>
                 <a:ea typeface="Calibri" pitchFamily="34" charset="-122"/>
@@ -7582,7 +7582,7 @@
             <a:r>
               <a:rPr lang="en-US" sz="1700" b="1" dirty="0">
                 <a:solidFill>
-                  <a:srgbClr val="C2410C"/>
+                  <a:srgbClr val="4C5CF0"/>
                 </a:solidFill>
                 <a:latin typeface="Calibri" pitchFamily="34" charset="0"/>
                 <a:ea typeface="Calibri" pitchFamily="34" charset="-122"/>
@@ -7621,7 +7621,7 @@
             <a:r>
               <a:rPr lang="en-US" sz="1400" dirty="0">
                 <a:solidFill>
-                  <a:srgbClr val="111827"/>
+                  <a:srgbClr val="14161C"/>
                 </a:solidFill>
                 <a:latin typeface="Calibri" pitchFamily="34" charset="0"/>
                 <a:ea typeface="Calibri" pitchFamily="34" charset="-122"/>
@@ -7687,7 +7687,7 @@
             <a:r>
               <a:rPr lang="en-US" sz="1700" b="1" dirty="0">
                 <a:solidFill>
-                  <a:srgbClr val="C2410C"/>
+                  <a:srgbClr val="4C5CF0"/>
                 </a:solidFill>
                 <a:latin typeface="Calibri" pitchFamily="34" charset="0"/>
                 <a:ea typeface="Calibri" pitchFamily="34" charset="-122"/>
@@ -7726,7 +7726,7 @@
             <a:r>
               <a:rPr lang="en-US" sz="1400" dirty="0">
                 <a:solidFill>
-                  <a:srgbClr val="111827"/>
+                  <a:srgbClr val="14161C"/>
                 </a:solidFill>
                 <a:latin typeface="Calibri" pitchFamily="34" charset="0"/>
                 <a:ea typeface="Calibri" pitchFamily="34" charset="-122"/>
@@ -7792,7 +7792,7 @@
             <a:r>
               <a:rPr lang="en-US" sz="1700" b="1" dirty="0">
                 <a:solidFill>
-                  <a:srgbClr val="C2410C"/>
+                  <a:srgbClr val="4C5CF0"/>
                 </a:solidFill>
                 <a:latin typeface="Calibri" pitchFamily="34" charset="0"/>
                 <a:ea typeface="Calibri" pitchFamily="34" charset="-122"/>
@@ -7831,7 +7831,7 @@
             <a:r>
               <a:rPr lang="en-US" sz="1400" dirty="0">
                 <a:solidFill>
-                  <a:srgbClr val="111827"/>
+                  <a:srgbClr val="14161C"/>
                 </a:solidFill>
                 <a:latin typeface="Calibri" pitchFamily="34" charset="0"/>
                 <a:ea typeface="Calibri" pitchFamily="34" charset="-122"/>
@@ -7897,7 +7897,7 @@
             <a:r>
               <a:rPr lang="en-US" sz="1700" b="1" dirty="0">
                 <a:solidFill>
-                  <a:srgbClr val="C2410C"/>
+                  <a:srgbClr val="4C5CF0"/>
                 </a:solidFill>
                 <a:latin typeface="Calibri" pitchFamily="34" charset="0"/>
                 <a:ea typeface="Calibri" pitchFamily="34" charset="-122"/>
@@ -7936,7 +7936,7 @@
             <a:r>
               <a:rPr lang="en-US" sz="1400" dirty="0">
                 <a:solidFill>
-                  <a:srgbClr val="111827"/>
+                  <a:srgbClr val="14161C"/>
                 </a:solidFill>
                 <a:latin typeface="Calibri" pitchFamily="34" charset="0"/>
                 <a:ea typeface="Calibri" pitchFamily="34" charset="-122"/>
@@ -8002,7 +8002,7 @@
             <a:r>
               <a:rPr lang="en-US" sz="1700" b="1" dirty="0">
                 <a:solidFill>
-                  <a:srgbClr val="C2410C"/>
+                  <a:srgbClr val="4C5CF0"/>
                 </a:solidFill>
                 <a:latin typeface="Calibri" pitchFamily="34" charset="0"/>
                 <a:ea typeface="Calibri" pitchFamily="34" charset="-122"/>
@@ -8041,7 +8041,7 @@
             <a:r>
               <a:rPr lang="en-US" sz="1400" dirty="0">
                 <a:solidFill>
-                  <a:srgbClr val="111827"/>
+                  <a:srgbClr val="14161C"/>
                 </a:solidFill>
                 <a:latin typeface="Calibri" pitchFamily="34" charset="0"/>
                 <a:ea typeface="Calibri" pitchFamily="34" charset="-122"/>
@@ -8100,11 +8100,11 @@
             <a:avLst/>
           </a:prstGeom>
           <a:solidFill>
-            <a:srgbClr val="C2410C"/>
+            <a:srgbClr val="4C5CF0"/>
           </a:solidFill>
           <a:ln w="12700">
             <a:solidFill>
-              <a:srgbClr val="C2410C"/>
+              <a:srgbClr val="4C5CF0"/>
             </a:solidFill>
             <a:prstDash val="solid"/>
           </a:ln>
@@ -8137,7 +8137,7 @@
             <a:r>
               <a:rPr lang="en-US" sz="1200" b="1" spc="200" kern="0" dirty="0">
                 <a:solidFill>
-                  <a:srgbClr val="C2410C"/>
+                  <a:srgbClr val="4C5CF0"/>
                 </a:solidFill>
                 <a:latin typeface="Calibri" pitchFamily="34" charset="0"/>
                 <a:ea typeface="Calibri" pitchFamily="34" charset="-122"/>
@@ -8176,7 +8176,7 @@
             <a:r>
               <a:rPr lang="en-US" sz="3000" b="1" dirty="0">
                 <a:solidFill>
-                  <a:srgbClr val="111827"/>
+                  <a:srgbClr val="14161C"/>
                 </a:solidFill>
                 <a:latin typeface="Calibri" pitchFamily="34" charset="0"/>
                 <a:ea typeface="Calibri" pitchFamily="34" charset="-122"/>
@@ -8293,7 +8293,7 @@
             <a:r>
               <a:rPr lang="en-US" sz="2000" b="1" dirty="0">
                 <a:solidFill>
-                  <a:srgbClr val="C2410C"/>
+                  <a:srgbClr val="4C5CF0"/>
                 </a:solidFill>
                 <a:latin typeface="Calibri" pitchFamily="34" charset="0"/>
                 <a:ea typeface="Calibri" pitchFamily="34" charset="-122"/>
@@ -8336,7 +8336,7 @@
             <a:r>
               <a:rPr lang="en-US" sz="1600" dirty="0">
                 <a:solidFill>
-                  <a:srgbClr val="111827"/>
+                  <a:srgbClr val="14161C"/>
                 </a:solidFill>
                 <a:latin typeface="Calibri" pitchFamily="34" charset="0"/>
                 <a:ea typeface="Calibri" pitchFamily="34" charset="-122"/>
@@ -8357,7 +8357,7 @@
             <a:r>
               <a:rPr lang="en-US" sz="1600" dirty="0">
                 <a:solidFill>
-                  <a:srgbClr val="111827"/>
+                  <a:srgbClr val="14161C"/>
                 </a:solidFill>
                 <a:latin typeface="Calibri" pitchFamily="34" charset="0"/>
                 <a:ea typeface="Calibri" pitchFamily="34" charset="-122"/>
@@ -8378,7 +8378,7 @@
             <a:r>
               <a:rPr lang="en-US" sz="1600" dirty="0">
                 <a:solidFill>
-                  <a:srgbClr val="111827"/>
+                  <a:srgbClr val="14161C"/>
                 </a:solidFill>
                 <a:latin typeface="Calibri" pitchFamily="34" charset="0"/>
                 <a:ea typeface="Calibri" pitchFamily="34" charset="-122"/>
@@ -8399,7 +8399,7 @@
             <a:r>
               <a:rPr lang="en-US" sz="1600" dirty="0">
                 <a:solidFill>
-                  <a:srgbClr val="111827"/>
+                  <a:srgbClr val="14161C"/>
                 </a:solidFill>
                 <a:latin typeface="Calibri" pitchFamily="34" charset="0"/>
                 <a:ea typeface="Calibri" pitchFamily="34" charset="-122"/>
@@ -8438,7 +8438,7 @@
             <a:r>
               <a:rPr lang="en-US" sz="2000" b="1" dirty="0">
                 <a:solidFill>
-                  <a:srgbClr val="C2410C"/>
+                  <a:srgbClr val="4C5CF0"/>
                 </a:solidFill>
                 <a:latin typeface="Calibri" pitchFamily="34" charset="0"/>
                 <a:ea typeface="Calibri" pitchFamily="34" charset="-122"/>
@@ -8481,7 +8481,7 @@
             <a:r>
               <a:rPr lang="en-US" sz="1600" dirty="0">
                 <a:solidFill>
-                  <a:srgbClr val="111827"/>
+                  <a:srgbClr val="14161C"/>
                 </a:solidFill>
                 <a:latin typeface="Calibri" pitchFamily="34" charset="0"/>
                 <a:ea typeface="Calibri" pitchFamily="34" charset="-122"/>
@@ -8502,7 +8502,7 @@
             <a:r>
               <a:rPr lang="en-US" sz="1600" dirty="0">
                 <a:solidFill>
-                  <a:srgbClr val="111827"/>
+                  <a:srgbClr val="14161C"/>
                 </a:solidFill>
                 <a:latin typeface="Calibri" pitchFamily="34" charset="0"/>
                 <a:ea typeface="Calibri" pitchFamily="34" charset="-122"/>
@@ -8523,7 +8523,7 @@
             <a:r>
               <a:rPr lang="en-US" sz="1600" dirty="0">
                 <a:solidFill>
-                  <a:srgbClr val="111827"/>
+                  <a:srgbClr val="14161C"/>
                 </a:solidFill>
                 <a:latin typeface="Calibri" pitchFamily="34" charset="0"/>
                 <a:ea typeface="Calibri" pitchFamily="34" charset="-122"/>
@@ -8544,7 +8544,7 @@
             <a:r>
               <a:rPr lang="en-US" sz="1600" dirty="0">
                 <a:solidFill>
-                  <a:srgbClr val="111827"/>
+                  <a:srgbClr val="14161C"/>
                 </a:solidFill>
                 <a:latin typeface="Calibri" pitchFamily="34" charset="0"/>
                 <a:ea typeface="Calibri" pitchFamily="34" charset="-122"/>
@@ -8565,7 +8565,7 @@
             <a:r>
               <a:rPr lang="en-US" sz="1600" dirty="0">
                 <a:solidFill>
-                  <a:srgbClr val="111827"/>
+                  <a:srgbClr val="14161C"/>
                 </a:solidFill>
                 <a:latin typeface="Calibri" pitchFamily="34" charset="0"/>
                 <a:ea typeface="Calibri" pitchFamily="34" charset="-122"/>
@@ -8586,7 +8586,7 @@
             <a:r>
               <a:rPr lang="en-US" sz="1600" dirty="0">
                 <a:solidFill>
-                  <a:srgbClr val="111827"/>
+                  <a:srgbClr val="14161C"/>
                 </a:solidFill>
                 <a:latin typeface="Calibri" pitchFamily="34" charset="0"/>
                 <a:ea typeface="Calibri" pitchFamily="34" charset="-122"/>
@@ -8645,11 +8645,11 @@
             <a:avLst/>
           </a:prstGeom>
           <a:solidFill>
-            <a:srgbClr val="C2410C"/>
+            <a:srgbClr val="4C5CF0"/>
           </a:solidFill>
           <a:ln w="12700">
             <a:solidFill>
-              <a:srgbClr val="C2410C"/>
+              <a:srgbClr val="4C5CF0"/>
             </a:solidFill>
             <a:prstDash val="solid"/>
           </a:ln>
@@ -8682,7 +8682,7 @@
             <a:r>
               <a:rPr lang="en-US" sz="1200" b="1" spc="200" kern="0" dirty="0">
                 <a:solidFill>
-                  <a:srgbClr val="C2410C"/>
+                  <a:srgbClr val="4C5CF0"/>
                 </a:solidFill>
                 <a:latin typeface="Calibri" pitchFamily="34" charset="0"/>
                 <a:ea typeface="Calibri" pitchFamily="34" charset="-122"/>
@@ -8721,7 +8721,7 @@
             <a:r>
               <a:rPr lang="en-US" sz="3000" b="1" dirty="0">
                 <a:solidFill>
-                  <a:srgbClr val="111827"/>
+                  <a:srgbClr val="14161C"/>
                 </a:solidFill>
                 <a:latin typeface="Calibri" pitchFamily="34" charset="0"/>
                 <a:ea typeface="Calibri" pitchFamily="34" charset="-122"/>
@@ -8865,7 +8865,7 @@
             <a:r>
               <a:rPr lang="en-US" sz="1700" b="1" dirty="0">
                 <a:solidFill>
-                  <a:srgbClr val="C2410C"/>
+                  <a:srgbClr val="4C5CF0"/>
                 </a:solidFill>
                 <a:latin typeface="Calibri" pitchFamily="34" charset="0"/>
                 <a:ea typeface="Calibri" pitchFamily="34" charset="-122"/>
@@ -8904,7 +8904,7 @@
             <a:r>
               <a:rPr lang="en-US" sz="1400" dirty="0">
                 <a:solidFill>
-                  <a:srgbClr val="111827"/>
+                  <a:srgbClr val="14161C"/>
                 </a:solidFill>
                 <a:latin typeface="Calibri" pitchFamily="34" charset="0"/>
                 <a:ea typeface="Calibri" pitchFamily="34" charset="-122"/>
@@ -8970,7 +8970,7 @@
             <a:r>
               <a:rPr lang="en-US" sz="1700" b="1" dirty="0">
                 <a:solidFill>
-                  <a:srgbClr val="C2410C"/>
+                  <a:srgbClr val="4C5CF0"/>
                 </a:solidFill>
                 <a:latin typeface="Calibri" pitchFamily="34" charset="0"/>
                 <a:ea typeface="Calibri" pitchFamily="34" charset="-122"/>
@@ -9009,7 +9009,7 @@
             <a:r>
               <a:rPr lang="en-US" sz="1400" dirty="0">
                 <a:solidFill>
-                  <a:srgbClr val="111827"/>
+                  <a:srgbClr val="14161C"/>
                 </a:solidFill>
                 <a:latin typeface="Calibri" pitchFamily="34" charset="0"/>
                 <a:ea typeface="Calibri" pitchFamily="34" charset="-122"/>
@@ -9075,7 +9075,7 @@
             <a:r>
               <a:rPr lang="en-US" sz="1700" b="1" dirty="0">
                 <a:solidFill>
-                  <a:srgbClr val="C2410C"/>
+                  <a:srgbClr val="4C5CF0"/>
                 </a:solidFill>
                 <a:latin typeface="Calibri" pitchFamily="34" charset="0"/>
                 <a:ea typeface="Calibri" pitchFamily="34" charset="-122"/>
@@ -9114,7 +9114,7 @@
             <a:r>
               <a:rPr lang="en-US" sz="1400" dirty="0">
                 <a:solidFill>
-                  <a:srgbClr val="111827"/>
+                  <a:srgbClr val="14161C"/>
                 </a:solidFill>
                 <a:latin typeface="Calibri" pitchFamily="34" charset="0"/>
                 <a:ea typeface="Calibri" pitchFamily="34" charset="-122"/>
@@ -9143,11 +9143,11 @@
             </a:avLst>
           </a:prstGeom>
           <a:solidFill>
-            <a:srgbClr val="FFF1E8"/>
+            <a:srgbClr val="E7E9FF"/>
           </a:solidFill>
           <a:ln w="12700">
             <a:solidFill>
-              <a:srgbClr val="C2410C"/>
+              <a:srgbClr val="4C5CF0"/>
             </a:solidFill>
             <a:prstDash val="solid"/>
           </a:ln>
@@ -9180,7 +9180,7 @@
             <a:r>
               <a:rPr lang="en-US" sz="1600" b="1" dirty="0">
                 <a:solidFill>
-                  <a:srgbClr val="C2410C"/>
+                  <a:srgbClr val="4C5CF0"/>
                 </a:solidFill>
                 <a:latin typeface="Calibri" pitchFamily="34" charset="0"/>
                 <a:ea typeface="Calibri" pitchFamily="34" charset="-122"/>
@@ -9195,7 +9195,7 @@
             <a:r>
               <a:rPr lang="en-US" sz="1600" dirty="0">
                 <a:solidFill>
-                  <a:srgbClr val="111827"/>
+                  <a:srgbClr val="14161C"/>
                 </a:solidFill>
                 <a:latin typeface="Calibri" pitchFamily="34" charset="0"/>
                 <a:ea typeface="Calibri" pitchFamily="34" charset="-122"/>
@@ -9210,7 +9210,7 @@
             <a:r>
               <a:rPr lang="en-US" sz="1600" dirty="0">
                 <a:solidFill>
-                  <a:srgbClr val="111827"/>
+                  <a:srgbClr val="14161C"/>
                 </a:solidFill>
                 <a:latin typeface="Calibri" pitchFamily="34" charset="0"/>
                 <a:ea typeface="Calibri" pitchFamily="34" charset="-122"/>
@@ -9269,11 +9269,11 @@
             <a:avLst/>
           </a:prstGeom>
           <a:solidFill>
-            <a:srgbClr val="C2410C"/>
+            <a:srgbClr val="4C5CF0"/>
           </a:solidFill>
           <a:ln w="12700">
             <a:solidFill>
-              <a:srgbClr val="C2410C"/>
+              <a:srgbClr val="4C5CF0"/>
             </a:solidFill>
             <a:prstDash val="solid"/>
           </a:ln>
@@ -9306,7 +9306,7 @@
             <a:r>
               <a:rPr lang="en-US" sz="1200" b="1" spc="200" kern="0" dirty="0">
                 <a:solidFill>
-                  <a:srgbClr val="C2410C"/>
+                  <a:srgbClr val="4C5CF0"/>
                 </a:solidFill>
                 <a:latin typeface="Calibri" pitchFamily="34" charset="0"/>
                 <a:ea typeface="Calibri" pitchFamily="34" charset="-122"/>
@@ -9345,7 +9345,7 @@
             <a:r>
               <a:rPr lang="en-US" sz="3000" b="1" dirty="0">
                 <a:solidFill>
-                  <a:srgbClr val="111827"/>
+                  <a:srgbClr val="14161C"/>
                 </a:solidFill>
                 <a:latin typeface="Calibri" pitchFamily="34" charset="0"/>
                 <a:ea typeface="Calibri" pitchFamily="34" charset="-122"/>
@@ -9466,7 +9466,7 @@
             <a:r>
               <a:rPr lang="en-US" sz="1900" dirty="0">
                 <a:solidFill>
-                  <a:srgbClr val="111827"/>
+                  <a:srgbClr val="14161C"/>
                 </a:solidFill>
                 <a:latin typeface="Calibri" pitchFamily="34" charset="0"/>
                 <a:ea typeface="Calibri" pitchFamily="34" charset="-122"/>
@@ -9487,7 +9487,7 @@
             <a:r>
               <a:rPr lang="en-US" sz="1900" dirty="0">
                 <a:solidFill>
-                  <a:srgbClr val="111827"/>
+                  <a:srgbClr val="14161C"/>
                 </a:solidFill>
                 <a:latin typeface="Calibri" pitchFamily="34" charset="0"/>
                 <a:ea typeface="Calibri" pitchFamily="34" charset="-122"/>
@@ -9508,7 +9508,7 @@
             <a:r>
               <a:rPr lang="en-US" sz="1900" dirty="0">
                 <a:solidFill>
-                  <a:srgbClr val="111827"/>
+                  <a:srgbClr val="14161C"/>
                 </a:solidFill>
                 <a:latin typeface="Calibri" pitchFamily="34" charset="0"/>
                 <a:ea typeface="Calibri" pitchFamily="34" charset="-122"/>
@@ -9529,7 +9529,7 @@
             <a:r>
               <a:rPr lang="en-US" sz="1900" dirty="0">
                 <a:solidFill>
-                  <a:srgbClr val="111827"/>
+                  <a:srgbClr val="14161C"/>
                 </a:solidFill>
                 <a:latin typeface="Calibri" pitchFamily="34" charset="0"/>
                 <a:ea typeface="Calibri" pitchFamily="34" charset="-122"/>
@@ -9550,7 +9550,7 @@
             <a:r>
               <a:rPr lang="en-US" sz="1900" dirty="0">
                 <a:solidFill>
-                  <a:srgbClr val="111827"/>
+                  <a:srgbClr val="14161C"/>
                 </a:solidFill>
                 <a:latin typeface="Calibri" pitchFamily="34" charset="0"/>
                 <a:ea typeface="Calibri" pitchFamily="34" charset="-122"/>
@@ -9571,7 +9571,7 @@
             <a:r>
               <a:rPr lang="en-US" sz="1900" dirty="0">
                 <a:solidFill>
-                  <a:srgbClr val="111827"/>
+                  <a:srgbClr val="14161C"/>
                 </a:solidFill>
                 <a:latin typeface="Calibri" pitchFamily="34" charset="0"/>
                 <a:ea typeface="Calibri" pitchFamily="34" charset="-122"/>
@@ -9630,11 +9630,11 @@
             <a:avLst/>
           </a:prstGeom>
           <a:solidFill>
-            <a:srgbClr val="C2410C"/>
+            <a:srgbClr val="4C5CF0"/>
           </a:solidFill>
           <a:ln w="12700">
             <a:solidFill>
-              <a:srgbClr val="C2410C"/>
+              <a:srgbClr val="4C5CF0"/>
             </a:solidFill>
             <a:prstDash val="solid"/>
           </a:ln>
@@ -9667,7 +9667,7 @@
             <a:r>
               <a:rPr lang="en-US" sz="1200" b="1" spc="200" kern="0" dirty="0">
                 <a:solidFill>
-                  <a:srgbClr val="C2410C"/>
+                  <a:srgbClr val="4C5CF0"/>
                 </a:solidFill>
                 <a:latin typeface="Calibri" pitchFamily="34" charset="0"/>
                 <a:ea typeface="Calibri" pitchFamily="34" charset="-122"/>
@@ -9706,7 +9706,7 @@
             <a:r>
               <a:rPr lang="en-US" sz="3000" b="1" dirty="0">
                 <a:solidFill>
-                  <a:srgbClr val="111827"/>
+                  <a:srgbClr val="14161C"/>
                 </a:solidFill>
                 <a:latin typeface="Calibri" pitchFamily="34" charset="0"/>
                 <a:ea typeface="Calibri" pitchFamily="34" charset="-122"/>
@@ -9887,7 +9887,7 @@
                       <a:tailEnd type="none" w="med" len="med"/>
                     </a:lnB>
                     <a:solidFill>
-                      <a:srgbClr val="111827"/>
+                      <a:srgbClr val="14161C"/>
                     </a:solidFill>
                   </a:tcPr>
                 </a:tc>
@@ -9955,7 +9955,7 @@
                       <a:tailEnd type="none" w="med" len="med"/>
                     </a:lnB>
                     <a:solidFill>
-                      <a:srgbClr val="111827"/>
+                      <a:srgbClr val="14161C"/>
                     </a:solidFill>
                   </a:tcPr>
                 </a:tc>
@@ -9972,7 +9972,7 @@
                       <a:r>
                         <a:rPr lang="en-US" sz="1500" dirty="0">
                           <a:solidFill>
-                            <a:srgbClr val="111827"/>
+                            <a:srgbClr val="14161C"/>
                           </a:solidFill>
                           <a:latin typeface="Calibri" pitchFamily="34" charset="0"/>
                           <a:ea typeface="Calibri" pitchFamily="34" charset="-122"/>
@@ -10040,7 +10040,7 @@
                       <a:r>
                         <a:rPr lang="en-US" sz="1500" dirty="0">
                           <a:solidFill>
-                            <a:srgbClr val="111827"/>
+                            <a:srgbClr val="14161C"/>
                           </a:solidFill>
                           <a:latin typeface="Calibri" pitchFamily="34" charset="0"/>
                           <a:ea typeface="Calibri" pitchFamily="34" charset="-122"/>
@@ -10110,7 +10110,7 @@
                       <a:r>
                         <a:rPr lang="en-US" sz="1500" dirty="0">
                           <a:solidFill>
-                            <a:srgbClr val="111827"/>
+                            <a:srgbClr val="14161C"/>
                           </a:solidFill>
                           <a:latin typeface="Calibri" pitchFamily="34" charset="0"/>
                           <a:ea typeface="Calibri" pitchFamily="34" charset="-122"/>
@@ -10178,7 +10178,7 @@
                       <a:r>
                         <a:rPr lang="en-US" sz="1500" dirty="0">
                           <a:solidFill>
-                            <a:srgbClr val="111827"/>
+                            <a:srgbClr val="14161C"/>
                           </a:solidFill>
                           <a:latin typeface="Calibri" pitchFamily="34" charset="0"/>
                           <a:ea typeface="Calibri" pitchFamily="34" charset="-122"/>
@@ -10248,7 +10248,7 @@
                       <a:r>
                         <a:rPr lang="en-US" sz="1500" dirty="0">
                           <a:solidFill>
-                            <a:srgbClr val="111827"/>
+                            <a:srgbClr val="14161C"/>
                           </a:solidFill>
                           <a:latin typeface="Calibri" pitchFamily="34" charset="0"/>
                           <a:ea typeface="Calibri" pitchFamily="34" charset="-122"/>
@@ -10316,7 +10316,7 @@
                       <a:r>
                         <a:rPr lang="en-US" sz="1500" dirty="0">
                           <a:solidFill>
-                            <a:srgbClr val="111827"/>
+                            <a:srgbClr val="14161C"/>
                           </a:solidFill>
                           <a:latin typeface="Calibri" pitchFamily="34" charset="0"/>
                           <a:ea typeface="Calibri" pitchFamily="34" charset="-122"/>
@@ -10386,7 +10386,7 @@
                       <a:r>
                         <a:rPr lang="en-US" sz="1500" dirty="0">
                           <a:solidFill>
-                            <a:srgbClr val="111827"/>
+                            <a:srgbClr val="14161C"/>
                           </a:solidFill>
                           <a:latin typeface="Calibri" pitchFamily="34" charset="0"/>
                           <a:ea typeface="Calibri" pitchFamily="34" charset="-122"/>
@@ -10454,7 +10454,7 @@
                       <a:r>
                         <a:rPr lang="en-US" sz="1500" dirty="0">
                           <a:solidFill>
-                            <a:srgbClr val="111827"/>
+                            <a:srgbClr val="14161C"/>
                           </a:solidFill>
                           <a:latin typeface="Calibri" pitchFamily="34" charset="0"/>
                           <a:ea typeface="Calibri" pitchFamily="34" charset="-122"/>
@@ -10524,7 +10524,7 @@
                       <a:r>
                         <a:rPr lang="en-US" sz="1500" dirty="0">
                           <a:solidFill>
-                            <a:srgbClr val="111827"/>
+                            <a:srgbClr val="14161C"/>
                           </a:solidFill>
                           <a:latin typeface="Calibri" pitchFamily="34" charset="0"/>
                           <a:ea typeface="Calibri" pitchFamily="34" charset="-122"/>
@@ -10592,7 +10592,7 @@
                       <a:r>
                         <a:rPr lang="en-US" sz="1500" dirty="0">
                           <a:solidFill>
-                            <a:srgbClr val="111827"/>
+                            <a:srgbClr val="14161C"/>
                           </a:solidFill>
                           <a:latin typeface="Calibri" pitchFamily="34" charset="0"/>
                           <a:ea typeface="Calibri" pitchFamily="34" charset="-122"/>
@@ -10662,7 +10662,7 @@
                       <a:r>
                         <a:rPr lang="en-US" sz="1500" dirty="0">
                           <a:solidFill>
-                            <a:srgbClr val="111827"/>
+                            <a:srgbClr val="14161C"/>
                           </a:solidFill>
                           <a:latin typeface="Calibri" pitchFamily="34" charset="0"/>
                           <a:ea typeface="Calibri" pitchFamily="34" charset="-122"/>
@@ -10730,13 +10730,13 @@
                       <a:r>
                         <a:rPr lang="en-US" sz="1500" dirty="0">
                           <a:solidFill>
-                            <a:srgbClr val="111827"/>
+                            <a:srgbClr val="14161C"/>
                           </a:solidFill>
                           <a:latin typeface="Calibri" pitchFamily="34" charset="0"/>
                           <a:ea typeface="Calibri" pitchFamily="34" charset="-122"/>
                           <a:cs typeface="Calibri" pitchFamily="34" charset="-120"/>
                         </a:rPr>
-                        <a:t>Full redesign: graphite + ember orange, light / dark / mobile</a:t>
+                        <a:t>Full redesign: warm canvas, pastel tiles, icon rail, docked AI assistant; light / dark / mobile</a:t>
                       </a:r>
                       <a:endParaRPr lang="en-US" sz="1500" dirty="0">
                         <a:latin typeface="Calibri" charset="0"/>
@@ -10819,7 +10819,7 @@
             <a:r>
               <a:rPr lang="en-US" sz="1600" b="1" dirty="0">
                 <a:solidFill>
-                  <a:srgbClr val="C2410C"/>
+                  <a:srgbClr val="4C5CF0"/>
                 </a:solidFill>
                 <a:latin typeface="Calibri" pitchFamily="34" charset="0"/>
                 <a:ea typeface="Calibri" pitchFamily="34" charset="-122"/>
@@ -10878,11 +10878,11 @@
             <a:avLst/>
           </a:prstGeom>
           <a:solidFill>
-            <a:srgbClr val="C2410C"/>
+            <a:srgbClr val="4C5CF0"/>
           </a:solidFill>
           <a:ln w="12700">
             <a:solidFill>
-              <a:srgbClr val="C2410C"/>
+              <a:srgbClr val="4C5CF0"/>
             </a:solidFill>
             <a:prstDash val="solid"/>
           </a:ln>
@@ -10915,7 +10915,7 @@
             <a:r>
               <a:rPr lang="en-US" sz="1200" b="1" spc="200" kern="0" dirty="0">
                 <a:solidFill>
-                  <a:srgbClr val="C2410C"/>
+                  <a:srgbClr val="4C5CF0"/>
                 </a:solidFill>
                 <a:latin typeface="Calibri" pitchFamily="34" charset="0"/>
                 <a:ea typeface="Calibri" pitchFamily="34" charset="-122"/>
@@ -10954,7 +10954,7 @@
             <a:r>
               <a:rPr lang="en-US" sz="3000" b="1" dirty="0">
                 <a:solidFill>
-                  <a:srgbClr val="111827"/>
+                  <a:srgbClr val="14161C"/>
                 </a:solidFill>
                 <a:latin typeface="Calibri" pitchFamily="34" charset="0"/>
                 <a:ea typeface="Calibri" pitchFamily="34" charset="-122"/>
@@ -11098,7 +11098,7 @@
             <a:r>
               <a:rPr lang="en-US" sz="1700" b="1" dirty="0">
                 <a:solidFill>
-                  <a:srgbClr val="C2410C"/>
+                  <a:srgbClr val="4C5CF0"/>
                 </a:solidFill>
                 <a:latin typeface="Calibri" pitchFamily="34" charset="0"/>
                 <a:ea typeface="Calibri" pitchFamily="34" charset="-122"/>
@@ -11137,7 +11137,7 @@
             <a:r>
               <a:rPr lang="en-US" sz="1400" dirty="0">
                 <a:solidFill>
-                  <a:srgbClr val="111827"/>
+                  <a:srgbClr val="14161C"/>
                 </a:solidFill>
                 <a:latin typeface="Calibri" pitchFamily="34" charset="0"/>
                 <a:ea typeface="Calibri" pitchFamily="34" charset="-122"/>
@@ -11203,7 +11203,7 @@
             <a:r>
               <a:rPr lang="en-US" sz="1700" b="1" dirty="0">
                 <a:solidFill>
-                  <a:srgbClr val="C2410C"/>
+                  <a:srgbClr val="4C5CF0"/>
                 </a:solidFill>
                 <a:latin typeface="Calibri" pitchFamily="34" charset="0"/>
                 <a:ea typeface="Calibri" pitchFamily="34" charset="-122"/>
@@ -11242,7 +11242,7 @@
             <a:r>
               <a:rPr lang="en-US" sz="1400" dirty="0">
                 <a:solidFill>
-                  <a:srgbClr val="111827"/>
+                  <a:srgbClr val="14161C"/>
                 </a:solidFill>
                 <a:latin typeface="Calibri" pitchFamily="34" charset="0"/>
                 <a:ea typeface="Calibri" pitchFamily="34" charset="-122"/>
@@ -11308,7 +11308,7 @@
             <a:r>
               <a:rPr lang="en-US" sz="1700" b="1" dirty="0">
                 <a:solidFill>
-                  <a:srgbClr val="C2410C"/>
+                  <a:srgbClr val="4C5CF0"/>
                 </a:solidFill>
                 <a:latin typeface="Calibri" pitchFamily="34" charset="0"/>
                 <a:ea typeface="Calibri" pitchFamily="34" charset="-122"/>
@@ -11347,7 +11347,7 @@
             <a:r>
               <a:rPr lang="en-US" sz="1400" dirty="0">
                 <a:solidFill>
-                  <a:srgbClr val="111827"/>
+                  <a:srgbClr val="14161C"/>
                 </a:solidFill>
                 <a:latin typeface="Calibri" pitchFamily="34" charset="0"/>
                 <a:ea typeface="Calibri" pitchFamily="34" charset="-122"/>
@@ -11451,7 +11451,7 @@
                       <a:tailEnd type="none" w="med" len="med"/>
                     </a:lnB>
                     <a:solidFill>
-                      <a:srgbClr val="111827"/>
+                      <a:srgbClr val="14161C"/>
                     </a:solidFill>
                   </a:tcPr>
                 </a:tc>
@@ -11519,7 +11519,7 @@
                       <a:tailEnd type="none" w="med" len="med"/>
                     </a:lnB>
                     <a:solidFill>
-                      <a:srgbClr val="111827"/>
+                      <a:srgbClr val="14161C"/>
                     </a:solidFill>
                   </a:tcPr>
                 </a:tc>
@@ -11587,7 +11587,7 @@
                       <a:tailEnd type="none" w="med" len="med"/>
                     </a:lnB>
                     <a:solidFill>
-                      <a:srgbClr val="111827"/>
+                      <a:srgbClr val="14161C"/>
                     </a:solidFill>
                   </a:tcPr>
                 </a:tc>
@@ -11604,7 +11604,7 @@
                       <a:r>
                         <a:rPr lang="en-US" sz="1400" dirty="0">
                           <a:solidFill>
-                            <a:srgbClr val="111827"/>
+                            <a:srgbClr val="14161C"/>
                           </a:solidFill>
                           <a:latin typeface="Calibri" pitchFamily="34" charset="0"/>
                           <a:ea typeface="Calibri" pitchFamily="34" charset="-122"/>
@@ -11672,7 +11672,7 @@
                       <a:r>
                         <a:rPr lang="en-US" sz="1400" dirty="0">
                           <a:solidFill>
-                            <a:srgbClr val="111827"/>
+                            <a:srgbClr val="14161C"/>
                           </a:solidFill>
                           <a:latin typeface="Calibri" pitchFamily="34" charset="0"/>
                           <a:ea typeface="Calibri" pitchFamily="34" charset="-122"/>
@@ -11740,7 +11740,7 @@
                       <a:r>
                         <a:rPr lang="en-US" sz="1400" dirty="0">
                           <a:solidFill>
-                            <a:srgbClr val="111827"/>
+                            <a:srgbClr val="14161C"/>
                           </a:solidFill>
                           <a:latin typeface="Calibri" pitchFamily="34" charset="0"/>
                           <a:ea typeface="Calibri" pitchFamily="34" charset="-122"/>
@@ -11810,7 +11810,7 @@
                       <a:r>
                         <a:rPr lang="en-US" sz="1400" dirty="0">
                           <a:solidFill>
-                            <a:srgbClr val="111827"/>
+                            <a:srgbClr val="14161C"/>
                           </a:solidFill>
                           <a:latin typeface="Calibri" pitchFamily="34" charset="0"/>
                           <a:ea typeface="Calibri" pitchFamily="34" charset="-122"/>
@@ -11878,7 +11878,7 @@
                       <a:r>
                         <a:rPr lang="en-US" sz="1400" dirty="0">
                           <a:solidFill>
-                            <a:srgbClr val="111827"/>
+                            <a:srgbClr val="14161C"/>
                           </a:solidFill>
                           <a:latin typeface="Calibri" pitchFamily="34" charset="0"/>
                           <a:ea typeface="Calibri" pitchFamily="34" charset="-122"/>
@@ -11946,7 +11946,7 @@
                       <a:r>
                         <a:rPr lang="en-US" sz="1400" dirty="0">
                           <a:solidFill>
-                            <a:srgbClr val="111827"/>
+                            <a:srgbClr val="14161C"/>
                           </a:solidFill>
                           <a:latin typeface="Calibri" pitchFamily="34" charset="0"/>
                           <a:ea typeface="Calibri" pitchFamily="34" charset="-122"/>
@@ -12016,7 +12016,7 @@
                       <a:r>
                         <a:rPr lang="en-US" sz="1400" dirty="0">
                           <a:solidFill>
-                            <a:srgbClr val="111827"/>
+                            <a:srgbClr val="14161C"/>
                           </a:solidFill>
                           <a:latin typeface="Calibri" pitchFamily="34" charset="0"/>
                           <a:ea typeface="Calibri" pitchFamily="34" charset="-122"/>
@@ -12084,7 +12084,7 @@
                       <a:r>
                         <a:rPr lang="en-US" sz="1400" dirty="0">
                           <a:solidFill>
-                            <a:srgbClr val="111827"/>
+                            <a:srgbClr val="14161C"/>
                           </a:solidFill>
                           <a:latin typeface="Calibri" pitchFamily="34" charset="0"/>
                           <a:ea typeface="Calibri" pitchFamily="34" charset="-122"/>
@@ -12152,7 +12152,7 @@
                       <a:r>
                         <a:rPr lang="en-US" sz="1400" dirty="0">
                           <a:solidFill>
-                            <a:srgbClr val="111827"/>
+                            <a:srgbClr val="14161C"/>
                           </a:solidFill>
                           <a:latin typeface="Calibri" pitchFamily="34" charset="0"/>
                           <a:ea typeface="Calibri" pitchFamily="34" charset="-122"/>
@@ -12222,7 +12222,7 @@
                       <a:r>
                         <a:rPr lang="en-US" sz="1400" dirty="0">
                           <a:solidFill>
-                            <a:srgbClr val="111827"/>
+                            <a:srgbClr val="14161C"/>
                           </a:solidFill>
                           <a:latin typeface="Calibri" pitchFamily="34" charset="0"/>
                           <a:ea typeface="Calibri" pitchFamily="34" charset="-122"/>
@@ -12290,7 +12290,7 @@
                       <a:r>
                         <a:rPr lang="en-US" sz="1400" dirty="0">
                           <a:solidFill>
-                            <a:srgbClr val="111827"/>
+                            <a:srgbClr val="14161C"/>
                           </a:solidFill>
                           <a:latin typeface="Calibri" pitchFamily="34" charset="0"/>
                           <a:ea typeface="Calibri" pitchFamily="34" charset="-122"/>
@@ -12358,7 +12358,7 @@
                       <a:r>
                         <a:rPr lang="en-US" sz="1400" dirty="0">
                           <a:solidFill>
-                            <a:srgbClr val="111827"/>
+                            <a:srgbClr val="14161C"/>
                           </a:solidFill>
                           <a:latin typeface="Calibri" pitchFamily="34" charset="0"/>
                           <a:ea typeface="Calibri" pitchFamily="34" charset="-122"/>
@@ -12467,11 +12467,11 @@
             <a:avLst/>
           </a:prstGeom>
           <a:solidFill>
-            <a:srgbClr val="C2410C"/>
+            <a:srgbClr val="4C5CF0"/>
           </a:solidFill>
           <a:ln w="12700">
             <a:solidFill>
-              <a:srgbClr val="C2410C"/>
+              <a:srgbClr val="4C5CF0"/>
             </a:solidFill>
             <a:prstDash val="solid"/>
           </a:ln>
@@ -12504,7 +12504,7 @@
             <a:r>
               <a:rPr lang="en-US" sz="1200" b="1" spc="200" kern="0" dirty="0">
                 <a:solidFill>
-                  <a:srgbClr val="C2410C"/>
+                  <a:srgbClr val="4C5CF0"/>
                 </a:solidFill>
                 <a:latin typeface="Calibri" pitchFamily="34" charset="0"/>
                 <a:ea typeface="Calibri" pitchFamily="34" charset="-122"/>
@@ -12543,7 +12543,7 @@
             <a:r>
               <a:rPr lang="en-US" sz="3000" b="1" dirty="0">
                 <a:solidFill>
-                  <a:srgbClr val="111827"/>
+                  <a:srgbClr val="14161C"/>
                 </a:solidFill>
                 <a:latin typeface="Calibri" pitchFamily="34" charset="0"/>
                 <a:ea typeface="Calibri" pitchFamily="34" charset="-122"/>
@@ -12664,7 +12664,7 @@
             <a:r>
               <a:rPr lang="en-US" sz="1800" dirty="0">
                 <a:solidFill>
-                  <a:srgbClr val="111827"/>
+                  <a:srgbClr val="14161C"/>
                 </a:solidFill>
                 <a:latin typeface="Calibri" pitchFamily="34" charset="0"/>
                 <a:ea typeface="Calibri" pitchFamily="34" charset="-122"/>
@@ -12685,7 +12685,7 @@
             <a:r>
               <a:rPr lang="en-US" sz="1800" dirty="0">
                 <a:solidFill>
-                  <a:srgbClr val="111827"/>
+                  <a:srgbClr val="14161C"/>
                 </a:solidFill>
                 <a:latin typeface="Calibri" pitchFamily="34" charset="0"/>
                 <a:ea typeface="Calibri" pitchFamily="34" charset="-122"/>
@@ -12706,7 +12706,7 @@
             <a:r>
               <a:rPr lang="en-US" sz="1800" dirty="0">
                 <a:solidFill>
-                  <a:srgbClr val="111827"/>
+                  <a:srgbClr val="14161C"/>
                 </a:solidFill>
                 <a:latin typeface="Calibri" pitchFamily="34" charset="0"/>
                 <a:ea typeface="Calibri" pitchFamily="34" charset="-122"/>
@@ -12727,7 +12727,7 @@
             <a:r>
               <a:rPr lang="en-US" sz="1800" dirty="0">
                 <a:solidFill>
-                  <a:srgbClr val="111827"/>
+                  <a:srgbClr val="14161C"/>
                 </a:solidFill>
                 <a:latin typeface="Calibri" pitchFamily="34" charset="0"/>
                 <a:ea typeface="Calibri" pitchFamily="34" charset="-122"/>
@@ -12748,7 +12748,7 @@
             <a:r>
               <a:rPr lang="en-US" sz="1800" dirty="0">
                 <a:solidFill>
-                  <a:srgbClr val="111827"/>
+                  <a:srgbClr val="14161C"/>
                 </a:solidFill>
                 <a:latin typeface="Calibri" pitchFamily="34" charset="0"/>
                 <a:ea typeface="Calibri" pitchFamily="34" charset="-122"/>
@@ -12769,7 +12769,7 @@
             <a:r>
               <a:rPr lang="en-US" sz="1800" dirty="0">
                 <a:solidFill>
-                  <a:srgbClr val="111827"/>
+                  <a:srgbClr val="14161C"/>
                 </a:solidFill>
                 <a:latin typeface="Calibri" pitchFamily="34" charset="0"/>
                 <a:ea typeface="Calibri" pitchFamily="34" charset="-122"/>
@@ -12828,11 +12828,11 @@
             <a:avLst/>
           </a:prstGeom>
           <a:solidFill>
-            <a:srgbClr val="C2410C"/>
+            <a:srgbClr val="4C5CF0"/>
           </a:solidFill>
           <a:ln w="12700">
             <a:solidFill>
-              <a:srgbClr val="C2410C"/>
+              <a:srgbClr val="4C5CF0"/>
             </a:solidFill>
             <a:prstDash val="solid"/>
           </a:ln>
@@ -12865,7 +12865,7 @@
             <a:r>
               <a:rPr lang="en-US" sz="1200" b="1" spc="200" kern="0" dirty="0">
                 <a:solidFill>
-                  <a:srgbClr val="C2410C"/>
+                  <a:srgbClr val="4C5CF0"/>
                 </a:solidFill>
                 <a:latin typeface="Calibri" pitchFamily="34" charset="0"/>
                 <a:ea typeface="Calibri" pitchFamily="34" charset="-122"/>
@@ -12904,7 +12904,7 @@
             <a:r>
               <a:rPr lang="en-US" sz="3000" b="1" dirty="0">
                 <a:solidFill>
-                  <a:srgbClr val="111827"/>
+                  <a:srgbClr val="14161C"/>
                 </a:solidFill>
                 <a:latin typeface="Calibri" pitchFamily="34" charset="0"/>
                 <a:ea typeface="Calibri" pitchFamily="34" charset="-122"/>
@@ -13104,11 +13104,11 @@
             <a:avLst/>
           </a:prstGeom>
           <a:solidFill>
-            <a:srgbClr val="C2410C"/>
+            <a:srgbClr val="4C5CF0"/>
           </a:solidFill>
           <a:ln w="12700">
             <a:solidFill>
-              <a:srgbClr val="C2410C"/>
+              <a:srgbClr val="4C5CF0"/>
             </a:solidFill>
             <a:prstDash val="solid"/>
           </a:ln>
@@ -13141,7 +13141,7 @@
             <a:r>
               <a:rPr lang="en-US" sz="1200" b="1" spc="200" kern="0" dirty="0">
                 <a:solidFill>
-                  <a:srgbClr val="C2410C"/>
+                  <a:srgbClr val="4C5CF0"/>
                 </a:solidFill>
                 <a:latin typeface="Calibri" pitchFamily="34" charset="0"/>
                 <a:ea typeface="Calibri" pitchFamily="34" charset="-122"/>
@@ -13180,7 +13180,7 @@
             <a:r>
               <a:rPr lang="en-US" sz="3000" b="1" dirty="0">
                 <a:solidFill>
-                  <a:srgbClr val="111827"/>
+                  <a:srgbClr val="14161C"/>
                 </a:solidFill>
                 <a:latin typeface="Calibri" pitchFamily="34" charset="0"/>
                 <a:ea typeface="Calibri" pitchFamily="34" charset="-122"/>
@@ -13341,11 +13341,11 @@
             <a:avLst/>
           </a:prstGeom>
           <a:solidFill>
-            <a:srgbClr val="C2410C"/>
+            <a:srgbClr val="4C5CF0"/>
           </a:solidFill>
           <a:ln w="12700">
             <a:solidFill>
-              <a:srgbClr val="C2410C"/>
+              <a:srgbClr val="4C5CF0"/>
             </a:solidFill>
             <a:prstDash val="solid"/>
           </a:ln>
@@ -13378,7 +13378,7 @@
             <a:r>
               <a:rPr lang="en-US" sz="1200" b="1" spc="200" kern="0" dirty="0">
                 <a:solidFill>
-                  <a:srgbClr val="C2410C"/>
+                  <a:srgbClr val="4C5CF0"/>
                 </a:solidFill>
                 <a:latin typeface="Calibri" pitchFamily="34" charset="0"/>
                 <a:ea typeface="Calibri" pitchFamily="34" charset="-122"/>
@@ -13417,7 +13417,7 @@
             <a:r>
               <a:rPr lang="en-US" sz="3000" b="1" dirty="0">
                 <a:solidFill>
-                  <a:srgbClr val="111827"/>
+                  <a:srgbClr val="14161C"/>
                 </a:solidFill>
                 <a:latin typeface="Calibri" pitchFamily="34" charset="0"/>
                 <a:ea typeface="Calibri" pitchFamily="34" charset="-122"/>
@@ -13524,11 +13524,11 @@
             </a:avLst>
           </a:prstGeom>
           <a:solidFill>
-            <a:srgbClr val="FFF1E8"/>
+            <a:srgbClr val="E7E9FF"/>
           </a:solidFill>
           <a:ln w="12700">
             <a:solidFill>
-              <a:srgbClr val="C2410C"/>
+              <a:srgbClr val="4C5CF0"/>
             </a:solidFill>
             <a:prstDash val="solid"/>
           </a:ln>
@@ -13561,7 +13561,7 @@
             <a:r>
               <a:rPr lang="en-US" sz="1700" b="1" dirty="0">
                 <a:solidFill>
-                  <a:srgbClr val="C2410C"/>
+                  <a:srgbClr val="4C5CF0"/>
                 </a:solidFill>
                 <a:latin typeface="Calibri" pitchFamily="34" charset="0"/>
                 <a:ea typeface="Calibri" pitchFamily="34" charset="-122"/>
@@ -13600,7 +13600,7 @@
             <a:r>
               <a:rPr lang="en-US" sz="1500" dirty="0">
                 <a:solidFill>
-                  <a:srgbClr val="111827"/>
+                  <a:srgbClr val="14161C"/>
                 </a:solidFill>
                 <a:latin typeface="Calibri" pitchFamily="34" charset="0"/>
                 <a:ea typeface="Calibri" pitchFamily="34" charset="-122"/>
@@ -13666,7 +13666,7 @@
             <a:r>
               <a:rPr lang="en-US" sz="1700" b="1" dirty="0">
                 <a:solidFill>
-                  <a:srgbClr val="C2410C"/>
+                  <a:srgbClr val="4C5CF0"/>
                 </a:solidFill>
                 <a:latin typeface="Calibri" pitchFamily="34" charset="0"/>
                 <a:ea typeface="Calibri" pitchFamily="34" charset="-122"/>
@@ -13705,7 +13705,7 @@
             <a:r>
               <a:rPr lang="en-US" sz="1500" dirty="0">
                 <a:solidFill>
-                  <a:srgbClr val="111827"/>
+                  <a:srgbClr val="14161C"/>
                 </a:solidFill>
                 <a:latin typeface="Calibri" pitchFamily="34" charset="0"/>
                 <a:ea typeface="Calibri" pitchFamily="34" charset="-122"/>
@@ -13771,7 +13771,7 @@
             <a:r>
               <a:rPr lang="en-US" sz="1700" b="1" dirty="0">
                 <a:solidFill>
-                  <a:srgbClr val="C2410C"/>
+                  <a:srgbClr val="4C5CF0"/>
                 </a:solidFill>
                 <a:latin typeface="Calibri" pitchFamily="34" charset="0"/>
                 <a:ea typeface="Calibri" pitchFamily="34" charset="-122"/>
@@ -13810,7 +13810,7 @@
             <a:r>
               <a:rPr lang="en-US" sz="1500" dirty="0">
                 <a:solidFill>
-                  <a:srgbClr val="111827"/>
+                  <a:srgbClr val="14161C"/>
                 </a:solidFill>
                 <a:latin typeface="Calibri" pitchFamily="34" charset="0"/>
                 <a:ea typeface="Calibri" pitchFamily="34" charset="-122"/>
@@ -13876,7 +13876,7 @@
             <a:r>
               <a:rPr lang="en-US" sz="1700" b="1" dirty="0">
                 <a:solidFill>
-                  <a:srgbClr val="C2410C"/>
+                  <a:srgbClr val="4C5CF0"/>
                 </a:solidFill>
                 <a:latin typeface="Calibri" pitchFamily="34" charset="0"/>
                 <a:ea typeface="Calibri" pitchFamily="34" charset="-122"/>
@@ -13915,7 +13915,7 @@
             <a:r>
               <a:rPr lang="en-US" sz="1500" dirty="0">
                 <a:solidFill>
-                  <a:srgbClr val="111827"/>
+                  <a:srgbClr val="14161C"/>
                 </a:solidFill>
                 <a:latin typeface="Calibri" pitchFamily="34" charset="0"/>
                 <a:ea typeface="Calibri" pitchFamily="34" charset="-122"/>
@@ -13981,7 +13981,7 @@
             <a:r>
               <a:rPr lang="en-US" sz="1700" b="1" dirty="0">
                 <a:solidFill>
-                  <a:srgbClr val="C2410C"/>
+                  <a:srgbClr val="4C5CF0"/>
                 </a:solidFill>
                 <a:latin typeface="Calibri" pitchFamily="34" charset="0"/>
                 <a:ea typeface="Calibri" pitchFamily="34" charset="-122"/>
@@ -14020,7 +14020,7 @@
             <a:r>
               <a:rPr lang="en-US" sz="1500" dirty="0">
                 <a:solidFill>
-                  <a:srgbClr val="111827"/>
+                  <a:srgbClr val="14161C"/>
                 </a:solidFill>
                 <a:latin typeface="Calibri" pitchFamily="34" charset="0"/>
                 <a:ea typeface="Calibri" pitchFamily="34" charset="-122"/>
@@ -14086,7 +14086,7 @@
             <a:r>
               <a:rPr lang="en-US" sz="1700" b="1" dirty="0">
                 <a:solidFill>
-                  <a:srgbClr val="C2410C"/>
+                  <a:srgbClr val="4C5CF0"/>
                 </a:solidFill>
                 <a:latin typeface="Calibri" pitchFamily="34" charset="0"/>
                 <a:ea typeface="Calibri" pitchFamily="34" charset="-122"/>
@@ -14125,7 +14125,7 @@
             <a:r>
               <a:rPr lang="en-US" sz="1500" dirty="0">
                 <a:solidFill>
-                  <a:srgbClr val="111827"/>
+                  <a:srgbClr val="14161C"/>
                 </a:solidFill>
                 <a:latin typeface="Calibri" pitchFamily="34" charset="0"/>
                 <a:ea typeface="Calibri" pitchFamily="34" charset="-122"/>

</xml_diff>

<commit_message>
Regenerate report and deck with new UI screenshots (settings, collapsible sidebar, accounts)
</commit_message>
<xml_diff>
--- a/report/Wealthline_Presentation.pptx
+++ b/report/Wealthline_Presentation.pptx
@@ -22,9 +22,10 @@
     <p:sldId id="270" r:id="rId16"/>
     <p:sldId id="271" r:id="rId17"/>
     <p:sldId id="272" r:id="rId18"/>
+    <p:sldId id="273" r:id="rId19"/>
   </p:sldIdLst>
   <p:notesMasterIdLst>
-    <p:notesMasterId r:id="rId19"/>
+    <p:notesMasterId r:id="rId20"/>
   </p:notesMasterIdLst>
   <p:sldSz cx="12192000" cy="6858000"/>
   <p:notesSz cx="6858000" cy="12192000"/>
@@ -1246,6 +1247,94 @@
             <a:fld id="{F7021451-1387-4CA6-816F-3879F97B5CBC}" type="slidenum">
               <a:rPr lang="en-US"/>
               <a:t>17</a:t>
+            </a:fld>
+            <a:endParaRPr lang="en-US"/>
+          </a:p>
+        </p:txBody>
+      </p:sp>
+    </p:spTree>
+    <p:extLst>
+      <p:ext uri="{BB962C8B-B14F-4D97-AF65-F5344CB8AC3E}">
+        <p14:creationId xmlns:p14="http://schemas.microsoft.com/office/powerpoint/2010/main" val="1024086991"/>
+      </p:ext>
+    </p:extLst>
+  </p:cSld>
+  <p:clrMapOvr>
+    <a:masterClrMapping/>
+  </p:clrMapOvr>
+</p:notes>
+</file>
+
+<file path=ppt/notesSlides/notesSlide18.xml><?xml version="1.0" encoding="utf-8"?>
+<p:notes xmlns:a="http://schemas.openxmlformats.org/drawingml/2006/main" xmlns:r="http://schemas.openxmlformats.org/officeDocument/2006/relationships" xmlns:p="http://schemas.openxmlformats.org/presentationml/2006/main">
+  <p:cSld>
+    <p:spTree>
+      <p:nvGrpSpPr>
+        <p:cNvPr id="1" name=""/>
+        <p:cNvGrpSpPr/>
+        <p:nvPr/>
+      </p:nvGrpSpPr>
+      <p:grpSpPr>
+        <a:xfrm>
+          <a:off x="0" y="0"/>
+          <a:ext cx="0" cy="0"/>
+          <a:chOff x="0" y="0"/>
+          <a:chExt cx="0" cy="0"/>
+        </a:xfrm>
+      </p:grpSpPr>
+      <p:sp>
+        <p:nvSpPr>
+          <p:cNvPr id="2" name="Slide Image Placeholder 1"/>
+          <p:cNvSpPr>
+            <a:spLocks noGrp="1" noRot="1" noChangeAspect="1"/>
+          </p:cNvSpPr>
+          <p:nvPr>
+            <p:ph type="sldImg"/>
+          </p:nvPr>
+        </p:nvSpPr>
+        <p:spPr/>
+      </p:sp>
+      <p:sp>
+        <p:nvSpPr>
+          <p:cNvPr id="3" name="Notes Placeholder 2"/>
+          <p:cNvSpPr>
+            <a:spLocks noGrp="1"/>
+          </p:cNvSpPr>
+          <p:nvPr>
+            <p:ph type="body" idx="1"/>
+          </p:nvPr>
+        </p:nvSpPr>
+        <p:spPr/>
+        <p:txBody>
+          <a:bodyPr/>
+          <a:lstStyle/>
+          <a:p>
+            <a:r>
+              <a:rPr lang="en-US" dirty="0"/>
+              <a:t/>
+            </a:r>
+            <a:endParaRPr lang="en-US" dirty="0"/>
+          </a:p>
+        </p:txBody>
+      </p:sp>
+      <p:sp>
+        <p:nvSpPr>
+          <p:cNvPr id="4" name="Slide Number Placeholder 3"/>
+          <p:cNvSpPr>
+            <a:spLocks noGrp="1"/>
+          </p:cNvSpPr>
+          <p:nvPr>
+            <p:ph type="sldNum" sz="quarter" idx="10"/>
+          </p:nvPr>
+        </p:nvSpPr>
+        <p:spPr/>
+        <p:txBody>
+          <a:bodyPr/>
+          <a:lstStyle/>
+          <a:p>
+            <a:fld id="{F7021451-1387-4CA6-816F-3879F97B5CBC}" type="slidenum">
+              <a:rPr lang="en-US"/>
+              <a:t>18</a:t>
             </a:fld>
             <a:endParaRPr lang="en-US"/>
           </a:p>
@@ -4225,7 +4314,7 @@
       </p:sp>
       <p:pic>
         <p:nvPicPr>
-          <p:cNvPr id="7" name="Image 0" descr="E:\Software-Metric\report\screenshots_v2\02-dashboard.png">    </p:cNvPr>
+          <p:cNvPr id="7" name="Image 0" descr="E:\Software-Metric\report\screenshots_v3\02-dashboard.png">    </p:cNvPr>
           <p:cNvPicPr>
             <a:picLocks noChangeAspect="1"/>
           </p:cNvPicPr>
@@ -4240,7 +4329,7 @@
         <p:spPr>
           <a:xfrm>
             <a:off x="548640" y="1371600"/>
-            <a:ext cx="5486400" cy="3429000"/>
+            <a:ext cx="5486400" cy="3086100"/>
           </a:xfrm>
           <a:prstGeom prst="rect">
             <a:avLst/>
@@ -4249,7 +4338,7 @@
       </p:pic>
       <p:pic>
         <p:nvPicPr>
-          <p:cNvPr id="8" name="Image 1" descr="E:\Software-Metric\report\screenshots_v2\04-scan-result.png">    </p:cNvPr>
+          <p:cNvPr id="8" name="Image 1" descr="E:\Software-Metric\report\screenshots_v3\04-scan-result.png">    </p:cNvPr>
           <p:cNvPicPr>
             <a:picLocks noChangeAspect="1"/>
           </p:cNvPicPr>
@@ -4264,7 +4353,7 @@
         <p:spPr>
           <a:xfrm>
             <a:off x="6172200" y="1371600"/>
-            <a:ext cx="5486400" cy="3429000"/>
+            <a:ext cx="5486400" cy="3086100"/>
           </a:xfrm>
           <a:prstGeom prst="rect">
             <a:avLst/>
@@ -4564,7 +4653,7 @@
       </p:sp>
       <p:pic>
         <p:nvPicPr>
-          <p:cNvPr id="7" name="Image 0" descr="E:\Software-Metric\report\screenshots_v2\10-insights.png">    </p:cNvPr>
+          <p:cNvPr id="7" name="Image 0" descr="E:\Software-Metric\report\screenshots_v3\10-insights.png">    </p:cNvPr>
           <p:cNvPicPr>
             <a:picLocks noChangeAspect="1"/>
           </p:cNvPicPr>
@@ -4579,7 +4668,7 @@
         <p:spPr>
           <a:xfrm>
             <a:off x="548640" y="1371600"/>
-            <a:ext cx="4480560" cy="2800350"/>
+            <a:ext cx="4480560" cy="2520315"/>
           </a:xfrm>
           <a:prstGeom prst="rect">
             <a:avLst/>
@@ -4588,7 +4677,7 @@
       </p:pic>
       <p:pic>
         <p:nvPicPr>
-          <p:cNvPr id="8" name="Image 1" descr="E:\Software-Metric\report\screenshots_v2\11-ask-ai.png">    </p:cNvPr>
+          <p:cNvPr id="8" name="Image 1" descr="E:\Software-Metric\report\screenshots_v3\11-ask-ai.png">    </p:cNvPr>
           <p:cNvPicPr>
             <a:picLocks noChangeAspect="1"/>
           </p:cNvPicPr>
@@ -4603,7 +4692,7 @@
         <p:spPr>
           <a:xfrm>
             <a:off x="5166360" y="1371600"/>
-            <a:ext cx="4480560" cy="2800350"/>
+            <a:ext cx="4480560" cy="2520315"/>
           </a:xfrm>
           <a:prstGeom prst="rect">
             <a:avLst/>
@@ -4612,7 +4701,7 @@
       </p:pic>
       <p:pic>
         <p:nvPicPr>
-          <p:cNvPr id="9" name="Image 2" descr="E:\Software-Metric\report\screenshots_v2\16-mobile-dashboard.png">    </p:cNvPr>
+          <p:cNvPr id="9" name="Image 2" descr="E:\Software-Metric\report\screenshots_v3\16-mobile-dashboard.png">    </p:cNvPr>
           <p:cNvPicPr>
             <a:picLocks noChangeAspect="1"/>
           </p:cNvPicPr>
@@ -4966,7 +5055,7 @@
       </p:sp>
       <p:pic>
         <p:nvPicPr>
-          <p:cNvPr id="7" name="Image 0" descr="E:\Software-Metric\report\screenshots_v2\06-budgets.png">    </p:cNvPr>
+          <p:cNvPr id="7" name="Image 0" descr="E:\Software-Metric\report\screenshots_v3\06-budgets.png">    </p:cNvPr>
           <p:cNvPicPr>
             <a:picLocks noChangeAspect="1"/>
           </p:cNvPicPr>
@@ -4981,7 +5070,7 @@
         <p:spPr>
           <a:xfrm>
             <a:off x="548640" y="1325880"/>
-            <a:ext cx="3657600" cy="2286000"/>
+            <a:ext cx="3657600" cy="2057400"/>
           </a:xfrm>
           <a:prstGeom prst="rect">
             <a:avLst/>
@@ -5029,7 +5118,7 @@
       </p:sp>
       <p:pic>
         <p:nvPicPr>
-          <p:cNvPr id="9" name="Image 1" descr="E:\Software-Metric\report\screenshots_v2\08-goals.png">    </p:cNvPr>
+          <p:cNvPr id="9" name="Image 1" descr="E:\Software-Metric\report\screenshots_v3\08-goals.png">    </p:cNvPr>
           <p:cNvPicPr>
             <a:picLocks noChangeAspect="1"/>
           </p:cNvPicPr>
@@ -5044,7 +5133,7 @@
         <p:spPr>
           <a:xfrm>
             <a:off x="6172200" y="1325880"/>
-            <a:ext cx="3657600" cy="2286000"/>
+            <a:ext cx="3657600" cy="2057400"/>
           </a:xfrm>
           <a:prstGeom prst="rect">
             <a:avLst/>
@@ -5092,7 +5181,7 @@
       </p:sp>
       <p:pic>
         <p:nvPicPr>
-          <p:cNvPr id="11" name="Image 2" descr="E:\Software-Metric\report\screenshots_v2\09-bills.png">    </p:cNvPr>
+          <p:cNvPr id="11" name="Image 2" descr="E:\Software-Metric\report\screenshots_v3\09-bills.png">    </p:cNvPr>
           <p:cNvPicPr>
             <a:picLocks noChangeAspect="1"/>
           </p:cNvPicPr>
@@ -5107,7 +5196,7 @@
         <p:spPr>
           <a:xfrm>
             <a:off x="548640" y="3931920"/>
-            <a:ext cx="3657600" cy="2286000"/>
+            <a:ext cx="3657600" cy="2057400"/>
           </a:xfrm>
           <a:prstGeom prst="rect">
             <a:avLst/>
@@ -5155,7 +5244,7 @@
       </p:sp>
       <p:pic>
         <p:nvPicPr>
-          <p:cNvPr id="13" name="Image 3" descr="E:\Software-Metric\report\screenshots_v2\14-dashboard-dark.png">    </p:cNvPr>
+          <p:cNvPr id="13" name="Image 3" descr="E:\Software-Metric\report\screenshots_v3\14-dashboard-dark.png">    </p:cNvPr>
           <p:cNvPicPr>
             <a:picLocks noChangeAspect="1"/>
           </p:cNvPicPr>
@@ -5170,7 +5259,7 @@
         <p:spPr>
           <a:xfrm>
             <a:off x="6172200" y="3931920"/>
-            <a:ext cx="3657600" cy="2286000"/>
+            <a:ext cx="3657600" cy="2057400"/>
           </a:xfrm>
           <a:prstGeom prst="rect">
             <a:avLst/>
@@ -5306,7 +5395,7 @@
                 <a:ea typeface="Calibri" pitchFamily="34" charset="-122"/>
                 <a:cs typeface="Calibri" pitchFamily="34" charset="-120"/>
               </a:rPr>
-              <a:t>PERFORMANCE OF THE WORKING MODEL</a:t>
+              <a:t>SCREENSHOT OF WORKING MODEL</a:t>
             </a:r>
             <a:endParaRPr lang="en-US" sz="1200" dirty="0"/>
           </a:p>
@@ -5345,7 +5434,7 @@
                 <a:ea typeface="Calibri" pitchFamily="34" charset="-122"/>
                 <a:cs typeface="Calibri" pitchFamily="34" charset="-120"/>
               </a:rPr>
-              <a:t>Measured results</a:t>
+              <a:t>Settings, collapsible sidebar and accounts</a:t>
             </a:r>
             <a:endParaRPr lang="en-US" sz="3000" dirty="0"/>
           </a:p>
@@ -5385,6 +5474,408 @@
                 <a:cs typeface="Calibri" pitchFamily="34" charset="-120"/>
               </a:rPr>
               <a:t>14</a:t>
+            </a:r>
+            <a:endParaRPr lang="en-US" sz="1100" dirty="0"/>
+          </a:p>
+        </p:txBody>
+      </p:sp>
+      <p:sp>
+        <p:nvSpPr>
+          <p:cNvPr id="6" name="Text 4"/>
+          <p:cNvSpPr/>
+          <p:nvPr/>
+        </p:nvSpPr>
+        <p:spPr>
+          <a:xfrm>
+            <a:off x="548640" y="6400800"/>
+            <a:ext cx="2743200" cy="274320"/>
+          </a:xfrm>
+          <a:prstGeom prst="rect">
+            <a:avLst/>
+          </a:prstGeom>
+          <a:noFill/>
+          <a:ln/>
+        </p:spPr>
+        <p:txBody>
+          <a:bodyPr wrap="square" rtlCol="0" anchor="ctr"/>
+          <a:lstStyle/>
+          <a:p>
+            <a:pPr indent="0" marL="0">
+              <a:buNone/>
+            </a:pPr>
+            <a:r>
+              <a:rPr lang="en-US" sz="1100" dirty="0">
+                <a:solidFill>
+                  <a:srgbClr val="4B5563"/>
+                </a:solidFill>
+                <a:latin typeface="Calibri" pitchFamily="34" charset="0"/>
+                <a:ea typeface="Calibri" pitchFamily="34" charset="-122"/>
+                <a:cs typeface="Calibri" pitchFamily="34" charset="-120"/>
+              </a:rPr>
+              <a:t>Wealthline</a:t>
+            </a:r>
+            <a:endParaRPr lang="en-US" sz="1100" dirty="0"/>
+          </a:p>
+        </p:txBody>
+      </p:sp>
+      <p:pic>
+        <p:nvPicPr>
+          <p:cNvPr id="7" name="Image 0" descr="E:\Software-Metric\report\screenshots_v3\17-settings.png">    </p:cNvPr>
+          <p:cNvPicPr>
+            <a:picLocks noChangeAspect="1"/>
+          </p:cNvPicPr>
+          <p:nvPr/>
+        </p:nvPicPr>
+        <p:blipFill>
+          <a:blip r:embed="rId1"/>
+          <a:stretch>
+            <a:fillRect/>
+          </a:stretch>
+        </p:blipFill>
+        <p:spPr>
+          <a:xfrm>
+            <a:off x="548640" y="1463040"/>
+            <a:ext cx="3566160" cy="2005965"/>
+          </a:xfrm>
+          <a:prstGeom prst="rect">
+            <a:avLst/>
+          </a:prstGeom>
+        </p:spPr>
+      </p:pic>
+      <p:sp>
+        <p:nvSpPr>
+          <p:cNvPr id="8" name="Text 5"/>
+          <p:cNvSpPr/>
+          <p:nvPr/>
+        </p:nvSpPr>
+        <p:spPr>
+          <a:xfrm>
+            <a:off x="548640" y="3566160"/>
+            <a:ext cx="3566160" cy="365760"/>
+          </a:xfrm>
+          <a:prstGeom prst="rect">
+            <a:avLst/>
+          </a:prstGeom>
+          <a:noFill/>
+          <a:ln/>
+        </p:spPr>
+        <p:txBody>
+          <a:bodyPr wrap="square" rtlCol="0" anchor="ctr"/>
+          <a:lstStyle/>
+          <a:p>
+            <a:pPr algn="ctr" indent="0" marL="0">
+              <a:buNone/>
+            </a:pPr>
+            <a:r>
+              <a:rPr lang="en-US" sz="1400" dirty="0">
+                <a:solidFill>
+                  <a:srgbClr val="4B5563"/>
+                </a:solidFill>
+                <a:latin typeface="Calibri" pitchFamily="34" charset="0"/>
+                <a:ea typeface="Calibri" pitchFamily="34" charset="-122"/>
+                <a:cs typeface="Calibri" pitchFamily="34" charset="-120"/>
+              </a:rPr>
+              <a:t>Account settings</a:t>
+            </a:r>
+            <a:endParaRPr lang="en-US" sz="1400" dirty="0"/>
+          </a:p>
+        </p:txBody>
+      </p:sp>
+      <p:pic>
+        <p:nvPicPr>
+          <p:cNvPr id="9" name="Image 1" descr="E:\Software-Metric\report\screenshots_v3\18-sidebar-collapsed.png">    </p:cNvPr>
+          <p:cNvPicPr>
+            <a:picLocks noChangeAspect="1"/>
+          </p:cNvPicPr>
+          <p:nvPr/>
+        </p:nvPicPr>
+        <p:blipFill>
+          <a:blip r:embed="rId2"/>
+          <a:stretch>
+            <a:fillRect/>
+          </a:stretch>
+        </p:blipFill>
+        <p:spPr>
+          <a:xfrm>
+            <a:off x="4297680" y="1463040"/>
+            <a:ext cx="3566160" cy="2005965"/>
+          </a:xfrm>
+          <a:prstGeom prst="rect">
+            <a:avLst/>
+          </a:prstGeom>
+        </p:spPr>
+      </p:pic>
+      <p:sp>
+        <p:nvSpPr>
+          <p:cNvPr id="10" name="Text 6"/>
+          <p:cNvSpPr/>
+          <p:nvPr/>
+        </p:nvSpPr>
+        <p:spPr>
+          <a:xfrm>
+            <a:off x="4297680" y="3566160"/>
+            <a:ext cx="3566160" cy="365760"/>
+          </a:xfrm>
+          <a:prstGeom prst="rect">
+            <a:avLst/>
+          </a:prstGeom>
+          <a:noFill/>
+          <a:ln/>
+        </p:spPr>
+        <p:txBody>
+          <a:bodyPr wrap="square" rtlCol="0" anchor="ctr"/>
+          <a:lstStyle/>
+          <a:p>
+            <a:pPr algn="ctr" indent="0" marL="0">
+              <a:buNone/>
+            </a:pPr>
+            <a:r>
+              <a:rPr lang="en-US" sz="1400" dirty="0">
+                <a:solidFill>
+                  <a:srgbClr val="4B5563"/>
+                </a:solidFill>
+                <a:latin typeface="Calibri" pitchFamily="34" charset="0"/>
+                <a:ea typeface="Calibri" pitchFamily="34" charset="-122"/>
+                <a:cs typeface="Calibri" pitchFamily="34" charset="-120"/>
+              </a:rPr>
+              <a:t>Collapsible sidebar</a:t>
+            </a:r>
+            <a:endParaRPr lang="en-US" sz="1400" dirty="0"/>
+          </a:p>
+        </p:txBody>
+      </p:sp>
+      <p:pic>
+        <p:nvPicPr>
+          <p:cNvPr id="11" name="Image 2" descr="E:\Software-Metric\report\screenshots_v3\09b-accounts.png">    </p:cNvPr>
+          <p:cNvPicPr>
+            <a:picLocks noChangeAspect="1"/>
+          </p:cNvPicPr>
+          <p:nvPr/>
+        </p:nvPicPr>
+        <p:blipFill>
+          <a:blip r:embed="rId3"/>
+          <a:stretch>
+            <a:fillRect/>
+          </a:stretch>
+        </p:blipFill>
+        <p:spPr>
+          <a:xfrm>
+            <a:off x="8046720" y="1463040"/>
+            <a:ext cx="3566160" cy="2005965"/>
+          </a:xfrm>
+          <a:prstGeom prst="rect">
+            <a:avLst/>
+          </a:prstGeom>
+        </p:spPr>
+      </p:pic>
+      <p:sp>
+        <p:nvSpPr>
+          <p:cNvPr id="12" name="Text 7"/>
+          <p:cNvSpPr/>
+          <p:nvPr/>
+        </p:nvSpPr>
+        <p:spPr>
+          <a:xfrm>
+            <a:off x="8046720" y="3566160"/>
+            <a:ext cx="3566160" cy="365760"/>
+          </a:xfrm>
+          <a:prstGeom prst="rect">
+            <a:avLst/>
+          </a:prstGeom>
+          <a:noFill/>
+          <a:ln/>
+        </p:spPr>
+        <p:txBody>
+          <a:bodyPr wrap="square" rtlCol="0" anchor="ctr"/>
+          <a:lstStyle/>
+          <a:p>
+            <a:pPr algn="ctr" indent="0" marL="0">
+              <a:buNone/>
+            </a:pPr>
+            <a:r>
+              <a:rPr lang="en-US" sz="1400" dirty="0">
+                <a:solidFill>
+                  <a:srgbClr val="4B5563"/>
+                </a:solidFill>
+                <a:latin typeface="Calibri" pitchFamily="34" charset="0"/>
+                <a:ea typeface="Calibri" pitchFamily="34" charset="-122"/>
+                <a:cs typeface="Calibri" pitchFamily="34" charset="-120"/>
+              </a:rPr>
+              <a:t>Accounts</a:t>
+            </a:r>
+            <a:endParaRPr lang="en-US" sz="1400" dirty="0"/>
+          </a:p>
+        </p:txBody>
+      </p:sp>
+    </p:spTree>
+  </p:cSld>
+  <p:clrMapOvr>
+    <a:masterClrMapping/>
+  </p:clrMapOvr>
+</p:sld>
+</file>
+
+<file path=ppt/slides/slide15.xml><?xml version="1.0" encoding="utf-8"?>
+<p:sld xmlns:a="http://schemas.openxmlformats.org/drawingml/2006/main" xmlns:r="http://schemas.openxmlformats.org/officeDocument/2006/relationships" xmlns:p="http://schemas.openxmlformats.org/presentationml/2006/main">
+  <p:cSld name="Slide 15">
+    <p:bg>
+      <p:bgPr>
+        <a:solidFill>
+          <a:srgbClr val="FFFFFF"/>
+        </a:solidFill>
+      </p:bgPr>
+    </p:bg>
+    <p:spTree>
+      <p:nvGrpSpPr>
+        <p:cNvPr id="1" name=""/>
+        <p:cNvGrpSpPr/>
+        <p:nvPr/>
+      </p:nvGrpSpPr>
+      <p:grpSpPr>
+        <a:xfrm>
+          <a:off x="0" y="0"/>
+          <a:ext cx="0" cy="0"/>
+          <a:chOff x="0" y="0"/>
+          <a:chExt cx="0" cy="0"/>
+        </a:xfrm>
+      </p:grpSpPr>
+      <p:sp>
+        <p:nvSpPr>
+          <p:cNvPr id="2" name="Shape 0"/>
+          <p:cNvSpPr/>
+          <p:nvPr/>
+        </p:nvSpPr>
+        <p:spPr>
+          <a:xfrm>
+            <a:off x="0" y="0"/>
+            <a:ext cx="164592" cy="6858000"/>
+          </a:xfrm>
+          <a:prstGeom prst="rect">
+            <a:avLst/>
+          </a:prstGeom>
+          <a:solidFill>
+            <a:srgbClr val="4C5CF0"/>
+          </a:solidFill>
+          <a:ln w="12700">
+            <a:solidFill>
+              <a:srgbClr val="4C5CF0"/>
+            </a:solidFill>
+            <a:prstDash val="solid"/>
+          </a:ln>
+        </p:spPr>
+      </p:sp>
+      <p:sp>
+        <p:nvSpPr>
+          <p:cNvPr id="3" name="Text 1"/>
+          <p:cNvSpPr/>
+          <p:nvPr/>
+        </p:nvSpPr>
+        <p:spPr>
+          <a:xfrm>
+            <a:off x="548640" y="274320"/>
+            <a:ext cx="8229600" cy="274320"/>
+          </a:xfrm>
+          <a:prstGeom prst="rect">
+            <a:avLst/>
+          </a:prstGeom>
+          <a:noFill/>
+          <a:ln/>
+        </p:spPr>
+        <p:txBody>
+          <a:bodyPr wrap="square" rtlCol="0" anchor="ctr"/>
+          <a:lstStyle/>
+          <a:p>
+            <a:pPr indent="0" marL="0">
+              <a:buNone/>
+            </a:pPr>
+            <a:r>
+              <a:rPr lang="en-US" sz="1200" b="1" spc="200" kern="0" dirty="0">
+                <a:solidFill>
+                  <a:srgbClr val="4C5CF0"/>
+                </a:solidFill>
+                <a:latin typeface="Calibri" pitchFamily="34" charset="0"/>
+                <a:ea typeface="Calibri" pitchFamily="34" charset="-122"/>
+                <a:cs typeface="Calibri" pitchFamily="34" charset="-120"/>
+              </a:rPr>
+              <a:t>PERFORMANCE OF THE WORKING MODEL</a:t>
+            </a:r>
+            <a:endParaRPr lang="en-US" sz="1200" dirty="0"/>
+          </a:p>
+        </p:txBody>
+      </p:sp>
+      <p:sp>
+        <p:nvSpPr>
+          <p:cNvPr id="4" name="Text 2"/>
+          <p:cNvSpPr/>
+          <p:nvPr/>
+        </p:nvSpPr>
+        <p:spPr>
+          <a:xfrm>
+            <a:off x="548640" y="530352"/>
+            <a:ext cx="11155680" cy="731520"/>
+          </a:xfrm>
+          <a:prstGeom prst="rect">
+            <a:avLst/>
+          </a:prstGeom>
+          <a:noFill/>
+          <a:ln/>
+        </p:spPr>
+        <p:txBody>
+          <a:bodyPr wrap="square" rtlCol="0" anchor="ctr"/>
+          <a:lstStyle/>
+          <a:p>
+            <a:pPr indent="0" marL="0">
+              <a:buNone/>
+            </a:pPr>
+            <a:r>
+              <a:rPr lang="en-US" sz="3000" b="1" dirty="0">
+                <a:solidFill>
+                  <a:srgbClr val="14161C"/>
+                </a:solidFill>
+                <a:latin typeface="Calibri" pitchFamily="34" charset="0"/>
+                <a:ea typeface="Calibri" pitchFamily="34" charset="-122"/>
+                <a:cs typeface="Calibri" pitchFamily="34" charset="-120"/>
+              </a:rPr>
+              <a:t>Measured results</a:t>
+            </a:r>
+            <a:endParaRPr lang="en-US" sz="3000" dirty="0"/>
+          </a:p>
+        </p:txBody>
+      </p:sp>
+      <p:sp>
+        <p:nvSpPr>
+          <p:cNvPr id="5" name="Text 3"/>
+          <p:cNvSpPr/>
+          <p:nvPr/>
+        </p:nvSpPr>
+        <p:spPr>
+          <a:xfrm>
+            <a:off x="11338560" y="6400800"/>
+            <a:ext cx="548640" cy="274320"/>
+          </a:xfrm>
+          <a:prstGeom prst="rect">
+            <a:avLst/>
+          </a:prstGeom>
+          <a:noFill/>
+          <a:ln/>
+        </p:spPr>
+        <p:txBody>
+          <a:bodyPr wrap="square" rtlCol="0" anchor="ctr"/>
+          <a:lstStyle/>
+          <a:p>
+            <a:pPr algn="r" indent="0" marL="0">
+              <a:buNone/>
+            </a:pPr>
+            <a:r>
+              <a:rPr lang="en-US" sz="1100" dirty="0">
+                <a:solidFill>
+                  <a:srgbClr val="4B5563"/>
+                </a:solidFill>
+                <a:latin typeface="Calibri" pitchFamily="34" charset="0"/>
+                <a:ea typeface="Calibri" pitchFamily="34" charset="-122"/>
+                <a:cs typeface="Calibri" pitchFamily="34" charset="-120"/>
+              </a:rPr>
+              <a:t>15</a:t>
             </a:r>
             <a:endParaRPr lang="en-US" sz="1100" dirty="0"/>
           </a:p>
@@ -5851,7 +6342,7 @@
       </p:sp>
       <p:graphicFrame>
         <p:nvGraphicFramePr>
-          <p:cNvPr id="15" name="Table 0"/>
+          <p:cNvPr id="16" name="Table 0"/>
           <p:cNvGraphicFramePr>
             <a:graphicFrameLocks noGrp="1"/>
           </p:cNvGraphicFramePr>
@@ -6918,306 +7409,6 @@
 </p:sld>
 </file>
 
-<file path=ppt/slides/slide15.xml><?xml version="1.0" encoding="utf-8"?>
-<p:sld xmlns:a="http://schemas.openxmlformats.org/drawingml/2006/main" xmlns:r="http://schemas.openxmlformats.org/officeDocument/2006/relationships" xmlns:p="http://schemas.openxmlformats.org/presentationml/2006/main">
-  <p:cSld name="Slide 15">
-    <p:bg>
-      <p:bgPr>
-        <a:solidFill>
-          <a:srgbClr val="FFFFFF"/>
-        </a:solidFill>
-      </p:bgPr>
-    </p:bg>
-    <p:spTree>
-      <p:nvGrpSpPr>
-        <p:cNvPr id="1" name=""/>
-        <p:cNvGrpSpPr/>
-        <p:nvPr/>
-      </p:nvGrpSpPr>
-      <p:grpSpPr>
-        <a:xfrm>
-          <a:off x="0" y="0"/>
-          <a:ext cx="0" cy="0"/>
-          <a:chOff x="0" y="0"/>
-          <a:chExt cx="0" cy="0"/>
-        </a:xfrm>
-      </p:grpSpPr>
-      <p:sp>
-        <p:nvSpPr>
-          <p:cNvPr id="2" name="Shape 0"/>
-          <p:cNvSpPr/>
-          <p:nvPr/>
-        </p:nvSpPr>
-        <p:spPr>
-          <a:xfrm>
-            <a:off x="0" y="0"/>
-            <a:ext cx="164592" cy="6858000"/>
-          </a:xfrm>
-          <a:prstGeom prst="rect">
-            <a:avLst/>
-          </a:prstGeom>
-          <a:solidFill>
-            <a:srgbClr val="4C5CF0"/>
-          </a:solidFill>
-          <a:ln w="12700">
-            <a:solidFill>
-              <a:srgbClr val="4C5CF0"/>
-            </a:solidFill>
-            <a:prstDash val="solid"/>
-          </a:ln>
-        </p:spPr>
-      </p:sp>
-      <p:sp>
-        <p:nvSpPr>
-          <p:cNvPr id="3" name="Text 1"/>
-          <p:cNvSpPr/>
-          <p:nvPr/>
-        </p:nvSpPr>
-        <p:spPr>
-          <a:xfrm>
-            <a:off x="548640" y="274320"/>
-            <a:ext cx="8229600" cy="274320"/>
-          </a:xfrm>
-          <a:prstGeom prst="rect">
-            <a:avLst/>
-          </a:prstGeom>
-          <a:noFill/>
-          <a:ln/>
-        </p:spPr>
-        <p:txBody>
-          <a:bodyPr wrap="square" rtlCol="0" anchor="ctr"/>
-          <a:lstStyle/>
-          <a:p>
-            <a:pPr indent="0" marL="0">
-              <a:buNone/>
-            </a:pPr>
-            <a:r>
-              <a:rPr lang="en-US" sz="1200" b="1" spc="200" kern="0" dirty="0">
-                <a:solidFill>
-                  <a:srgbClr val="4C5CF0"/>
-                </a:solidFill>
-                <a:latin typeface="Calibri" pitchFamily="34" charset="0"/>
-                <a:ea typeface="Calibri" pitchFamily="34" charset="-122"/>
-                <a:cs typeface="Calibri" pitchFamily="34" charset="-120"/>
-              </a:rPr>
-              <a:t>PERFORMANCE — METRICS ANALYSIS</a:t>
-            </a:r>
-            <a:endParaRPr lang="en-US" sz="1200" dirty="0"/>
-          </a:p>
-        </p:txBody>
-      </p:sp>
-      <p:sp>
-        <p:nvSpPr>
-          <p:cNvPr id="4" name="Text 2"/>
-          <p:cNvSpPr/>
-          <p:nvPr/>
-        </p:nvSpPr>
-        <p:spPr>
-          <a:xfrm>
-            <a:off x="548640" y="530352"/>
-            <a:ext cx="11155680" cy="731520"/>
-          </a:xfrm>
-          <a:prstGeom prst="rect">
-            <a:avLst/>
-          </a:prstGeom>
-          <a:noFill/>
-          <a:ln/>
-        </p:spPr>
-        <p:txBody>
-          <a:bodyPr wrap="square" rtlCol="0" anchor="ctr"/>
-          <a:lstStyle/>
-          <a:p>
-            <a:pPr indent="0" marL="0">
-              <a:buNone/>
-            </a:pPr>
-            <a:r>
-              <a:rPr lang="en-US" sz="3000" b="1" dirty="0">
-                <a:solidFill>
-                  <a:srgbClr val="14161C"/>
-                </a:solidFill>
-                <a:latin typeface="Calibri" pitchFamily="34" charset="0"/>
-                <a:ea typeface="Calibri" pitchFamily="34" charset="-122"/>
-                <a:cs typeface="Calibri" pitchFamily="34" charset="-120"/>
-              </a:rPr>
-              <a:t>Module 3 and 4 analysis in the app</a:t>
-            </a:r>
-            <a:endParaRPr lang="en-US" sz="3000" dirty="0"/>
-          </a:p>
-        </p:txBody>
-      </p:sp>
-      <p:sp>
-        <p:nvSpPr>
-          <p:cNvPr id="5" name="Text 3"/>
-          <p:cNvSpPr/>
-          <p:nvPr/>
-        </p:nvSpPr>
-        <p:spPr>
-          <a:xfrm>
-            <a:off x="11338560" y="6400800"/>
-            <a:ext cx="548640" cy="274320"/>
-          </a:xfrm>
-          <a:prstGeom prst="rect">
-            <a:avLst/>
-          </a:prstGeom>
-          <a:noFill/>
-          <a:ln/>
-        </p:spPr>
-        <p:txBody>
-          <a:bodyPr wrap="square" rtlCol="0" anchor="ctr"/>
-          <a:lstStyle/>
-          <a:p>
-            <a:pPr algn="r" indent="0" marL="0">
-              <a:buNone/>
-            </a:pPr>
-            <a:r>
-              <a:rPr lang="en-US" sz="1100" dirty="0">
-                <a:solidFill>
-                  <a:srgbClr val="4B5563"/>
-                </a:solidFill>
-                <a:latin typeface="Calibri" pitchFamily="34" charset="0"/>
-                <a:ea typeface="Calibri" pitchFamily="34" charset="-122"/>
-                <a:cs typeface="Calibri" pitchFamily="34" charset="-120"/>
-              </a:rPr>
-              <a:t>15</a:t>
-            </a:r>
-            <a:endParaRPr lang="en-US" sz="1100" dirty="0"/>
-          </a:p>
-        </p:txBody>
-      </p:sp>
-      <p:sp>
-        <p:nvSpPr>
-          <p:cNvPr id="6" name="Text 4"/>
-          <p:cNvSpPr/>
-          <p:nvPr/>
-        </p:nvSpPr>
-        <p:spPr>
-          <a:xfrm>
-            <a:off x="548640" y="6400800"/>
-            <a:ext cx="2743200" cy="274320"/>
-          </a:xfrm>
-          <a:prstGeom prst="rect">
-            <a:avLst/>
-          </a:prstGeom>
-          <a:noFill/>
-          <a:ln/>
-        </p:spPr>
-        <p:txBody>
-          <a:bodyPr wrap="square" rtlCol="0" anchor="ctr"/>
-          <a:lstStyle/>
-          <a:p>
-            <a:pPr indent="0" marL="0">
-              <a:buNone/>
-            </a:pPr>
-            <a:r>
-              <a:rPr lang="en-US" sz="1100" dirty="0">
-                <a:solidFill>
-                  <a:srgbClr val="4B5563"/>
-                </a:solidFill>
-                <a:latin typeface="Calibri" pitchFamily="34" charset="0"/>
-                <a:ea typeface="Calibri" pitchFamily="34" charset="-122"/>
-                <a:cs typeface="Calibri" pitchFamily="34" charset="-120"/>
-              </a:rPr>
-              <a:t>Wealthline</a:t>
-            </a:r>
-            <a:endParaRPr lang="en-US" sz="1100" dirty="0"/>
-          </a:p>
-        </p:txBody>
-      </p:sp>
-      <p:pic>
-        <p:nvPicPr>
-          <p:cNvPr id="7" name="Image 0" descr="E:\Software-Metric\charts\control_chart.png">    </p:cNvPr>
-          <p:cNvPicPr>
-            <a:picLocks noChangeAspect="1"/>
-          </p:cNvPicPr>
-          <p:nvPr/>
-        </p:nvPicPr>
-        <p:blipFill>
-          <a:blip r:embed="rId1"/>
-          <a:stretch>
-            <a:fillRect/>
-          </a:stretch>
-        </p:blipFill>
-        <p:spPr>
-          <a:xfrm>
-            <a:off x="548640" y="1371600"/>
-            <a:ext cx="4206240" cy="2676698"/>
-          </a:xfrm>
-          <a:prstGeom prst="rect">
-            <a:avLst/>
-          </a:prstGeom>
-        </p:spPr>
-      </p:pic>
-      <p:pic>
-        <p:nvPicPr>
-          <p:cNvPr id="8" name="Image 1" descr="E:\Software-Metric\charts\decision_tree.png">    </p:cNvPr>
-          <p:cNvPicPr>
-            <a:picLocks noChangeAspect="1"/>
-          </p:cNvPicPr>
-          <p:nvPr/>
-        </p:nvPicPr>
-        <p:blipFill>
-          <a:blip r:embed="rId2"/>
-          <a:stretch>
-            <a:fillRect/>
-          </a:stretch>
-        </p:blipFill>
-        <p:spPr>
-          <a:xfrm>
-            <a:off x="4937760" y="1371600"/>
-            <a:ext cx="6675120" cy="3594295"/>
-          </a:xfrm>
-          <a:prstGeom prst="rect">
-            <a:avLst/>
-          </a:prstGeom>
-        </p:spPr>
-      </p:pic>
-      <p:sp>
-        <p:nvSpPr>
-          <p:cNvPr id="9" name="Text 5"/>
-          <p:cNvSpPr/>
-          <p:nvPr/>
-        </p:nvSpPr>
-        <p:spPr>
-          <a:xfrm>
-            <a:off x="548640" y="5257800"/>
-            <a:ext cx="11064240" cy="822960"/>
-          </a:xfrm>
-          <a:prstGeom prst="rect">
-            <a:avLst/>
-          </a:prstGeom>
-          <a:noFill/>
-          <a:ln/>
-        </p:spPr>
-        <p:txBody>
-          <a:bodyPr wrap="square" rtlCol="0" anchor="ctr"/>
-          <a:lstStyle/>
-          <a:p>
-            <a:pPr indent="0" marL="0">
-              <a:buNone/>
-            </a:pPr>
-            <a:r>
-              <a:rPr lang="en-US" sz="1600" b="1" dirty="0">
-                <a:solidFill>
-                  <a:srgbClr val="14161C"/>
-                </a:solidFill>
-                <a:latin typeface="Calibri" pitchFamily="34" charset="0"/>
-                <a:ea typeface="Calibri" pitchFamily="34" charset="-122"/>
-                <a:cs typeface="Calibri" pitchFamily="34" charset="-120"/>
-              </a:rPr>
-              <a:t>I-MR chart flags week 12.  Complexity ↔ defect density positive under Pearson, Spearman and Kendall.  P(High project risk): 28% baseline → 55% worst case → 27% with team upskilling.</a:t>
-            </a:r>
-            <a:endParaRPr lang="en-US" sz="1600" dirty="0"/>
-          </a:p>
-        </p:txBody>
-      </p:sp>
-    </p:spTree>
-  </p:cSld>
-  <p:clrMapOvr>
-    <a:masterClrMapping/>
-  </p:clrMapOvr>
-</p:sld>
-</file>
-
 <file path=ppt/slides/slide16.xml><?xml version="1.0" encoding="utf-8"?>
 <p:sld xmlns:a="http://schemas.openxmlformats.org/drawingml/2006/main" xmlns:r="http://schemas.openxmlformats.org/officeDocument/2006/relationships" xmlns:p="http://schemas.openxmlformats.org/presentationml/2006/main">
   <p:cSld name="Slide 16">
@@ -7300,7 +7491,7 @@
                 <a:ea typeface="Calibri" pitchFamily="34" charset="-122"/>
                 <a:cs typeface="Calibri" pitchFamily="34" charset="-120"/>
               </a:rPr>
-              <a:t>NOVELTY AND INNOVATION / JUSTIFICATION</a:t>
+              <a:t>PERFORMANCE — METRICS ANALYSIS</a:t>
             </a:r>
             <a:endParaRPr lang="en-US" sz="1200" dirty="0"/>
           </a:p>
@@ -7339,7 +7530,7 @@
                 <a:ea typeface="Calibri" pitchFamily="34" charset="-122"/>
                 <a:cs typeface="Calibri" pitchFamily="34" charset="-120"/>
               </a:rPr>
-              <a:t>Why this is different — and why it is justified</a:t>
+              <a:t>Module 3 and 4 analysis in the app</a:t>
             </a:r>
             <a:endParaRPr lang="en-US" sz="3000" dirty="0"/>
           </a:p>
@@ -7423,43 +7614,64 @@
           </a:p>
         </p:txBody>
       </p:sp>
-      <p:sp>
-        <p:nvSpPr>
-          <p:cNvPr id="7" name="Shape 5"/>
-          <p:cNvSpPr/>
-          <p:nvPr/>
-        </p:nvSpPr>
-        <p:spPr>
-          <a:xfrm>
-            <a:off x="548640" y="1463040"/>
-            <a:ext cx="3566160" cy="2331720"/>
-          </a:xfrm>
-          <a:prstGeom prst="roundRect">
-            <a:avLst>
-              <a:gd name="adj" fmla="val 3137"/>
-            </a:avLst>
-          </a:prstGeom>
-          <a:solidFill>
-            <a:srgbClr val="F5F6FA"/>
-          </a:solidFill>
-          <a:ln w="12700">
-            <a:solidFill>
-              <a:srgbClr val="D1D5DB"/>
-            </a:solidFill>
-            <a:prstDash val="solid"/>
-          </a:ln>
-        </p:spPr>
-      </p:sp>
-      <p:sp>
-        <p:nvSpPr>
-          <p:cNvPr id="8" name="Text 6"/>
-          <p:cNvSpPr/>
-          <p:nvPr/>
-        </p:nvSpPr>
-        <p:spPr>
-          <a:xfrm>
-            <a:off x="731520" y="1572768"/>
-            <a:ext cx="3200400" cy="365760"/>
+      <p:pic>
+        <p:nvPicPr>
+          <p:cNvPr id="7" name="Image 0" descr="E:\Software-Metric\charts\control_chart.png">    </p:cNvPr>
+          <p:cNvPicPr>
+            <a:picLocks noChangeAspect="1"/>
+          </p:cNvPicPr>
+          <p:nvPr/>
+        </p:nvPicPr>
+        <p:blipFill>
+          <a:blip r:embed="rId1"/>
+          <a:stretch>
+            <a:fillRect/>
+          </a:stretch>
+        </p:blipFill>
+        <p:spPr>
+          <a:xfrm>
+            <a:off x="548640" y="1371600"/>
+            <a:ext cx="4206240" cy="2676698"/>
+          </a:xfrm>
+          <a:prstGeom prst="rect">
+            <a:avLst/>
+          </a:prstGeom>
+        </p:spPr>
+      </p:pic>
+      <p:pic>
+        <p:nvPicPr>
+          <p:cNvPr id="8" name="Image 1" descr="E:\Software-Metric\charts\decision_tree.png">    </p:cNvPr>
+          <p:cNvPicPr>
+            <a:picLocks noChangeAspect="1"/>
+          </p:cNvPicPr>
+          <p:nvPr/>
+        </p:nvPicPr>
+        <p:blipFill>
+          <a:blip r:embed="rId2"/>
+          <a:stretch>
+            <a:fillRect/>
+          </a:stretch>
+        </p:blipFill>
+        <p:spPr>
+          <a:xfrm>
+            <a:off x="4937760" y="1371600"/>
+            <a:ext cx="6675120" cy="3594295"/>
+          </a:xfrm>
+          <a:prstGeom prst="rect">
+            <a:avLst/>
+          </a:prstGeom>
+        </p:spPr>
+      </p:pic>
+      <p:sp>
+        <p:nvSpPr>
+          <p:cNvPr id="9" name="Text 5"/>
+          <p:cNvSpPr/>
+          <p:nvPr/>
+        </p:nvSpPr>
+        <p:spPr>
+          <a:xfrm>
+            <a:off x="548640" y="5257800"/>
+            <a:ext cx="11064240" cy="822960"/>
           </a:xfrm>
           <a:prstGeom prst="rect">
             <a:avLst/>
@@ -7475,46 +7687,7 @@
               <a:buNone/>
             </a:pPr>
             <a:r>
-              <a:rPr lang="en-US" sz="1700" b="1" dirty="0">
-                <a:solidFill>
-                  <a:srgbClr val="4C5CF0"/>
-                </a:solidFill>
-                <a:latin typeface="Calibri" pitchFamily="34" charset="0"/>
-                <a:ea typeface="Calibri" pitchFamily="34" charset="-122"/>
-                <a:cs typeface="Calibri" pitchFamily="34" charset="-120"/>
-              </a:rPr>
-              <a:t>AI proposes, code verifies</a:t>
-            </a:r>
-            <a:endParaRPr lang="en-US" sz="1700" dirty="0"/>
-          </a:p>
-        </p:txBody>
-      </p:sp>
-      <p:sp>
-        <p:nvSpPr>
-          <p:cNvPr id="9" name="Text 7"/>
-          <p:cNvSpPr/>
-          <p:nvPr/>
-        </p:nvSpPr>
-        <p:spPr>
-          <a:xfrm>
-            <a:off x="731520" y="1965960"/>
-            <a:ext cx="3200400" cy="1737360"/>
-          </a:xfrm>
-          <a:prstGeom prst="rect">
-            <a:avLst/>
-          </a:prstGeom>
-          <a:noFill/>
-          <a:ln/>
-        </p:spPr>
-        <p:txBody>
-          <a:bodyPr wrap="square" rtlCol="0" anchor="t"/>
-          <a:lstStyle/>
-          <a:p>
-            <a:pPr indent="0" marL="0">
-              <a:buNone/>
-            </a:pPr>
-            <a:r>
-              <a:rPr lang="en-US" sz="1400" dirty="0">
+              <a:rPr lang="en-US" sz="1600" b="1" dirty="0">
                 <a:solidFill>
                   <a:srgbClr val="14161C"/>
                 </a:solidFill>
@@ -7522,534 +7695,9 @@
                 <a:ea typeface="Calibri" pitchFamily="34" charset="-122"/>
                 <a:cs typeface="Calibri" pitchFamily="34" charset="-120"/>
               </a:rPr>
-              <a:t>The model only reads the bill. Budget impact, duplicate and date checks are deterministic server code; the user confirms.</a:t>
-            </a:r>
-            <a:endParaRPr lang="en-US" sz="1400" dirty="0"/>
-          </a:p>
-        </p:txBody>
-      </p:sp>
-      <p:sp>
-        <p:nvSpPr>
-          <p:cNvPr id="10" name="Shape 8"/>
-          <p:cNvSpPr/>
-          <p:nvPr/>
-        </p:nvSpPr>
-        <p:spPr>
-          <a:xfrm>
-            <a:off x="4297680" y="1463040"/>
-            <a:ext cx="3566160" cy="2331720"/>
-          </a:xfrm>
-          <a:prstGeom prst="roundRect">
-            <a:avLst>
-              <a:gd name="adj" fmla="val 3137"/>
-            </a:avLst>
-          </a:prstGeom>
-          <a:solidFill>
-            <a:srgbClr val="F5F6FA"/>
-          </a:solidFill>
-          <a:ln w="12700">
-            <a:solidFill>
-              <a:srgbClr val="D1D5DB"/>
-            </a:solidFill>
-            <a:prstDash val="solid"/>
-          </a:ln>
-        </p:spPr>
-      </p:sp>
-      <p:sp>
-        <p:nvSpPr>
-          <p:cNvPr id="11" name="Text 9"/>
-          <p:cNvSpPr/>
-          <p:nvPr/>
-        </p:nvSpPr>
-        <p:spPr>
-          <a:xfrm>
-            <a:off x="4480560" y="1572768"/>
-            <a:ext cx="3200400" cy="365760"/>
-          </a:xfrm>
-          <a:prstGeom prst="rect">
-            <a:avLst/>
-          </a:prstGeom>
-          <a:noFill/>
-          <a:ln/>
-        </p:spPr>
-        <p:txBody>
-          <a:bodyPr wrap="square" rtlCol="0" anchor="ctr"/>
-          <a:lstStyle/>
-          <a:p>
-            <a:pPr indent="0" marL="0">
-              <a:buNone/>
-            </a:pPr>
-            <a:r>
-              <a:rPr lang="en-US" sz="1700" b="1" dirty="0">
-                <a:solidFill>
-                  <a:srgbClr val="4C5CF0"/>
-                </a:solidFill>
-                <a:latin typeface="Calibri" pitchFamily="34" charset="0"/>
-                <a:ea typeface="Calibri" pitchFamily="34" charset="-122"/>
-                <a:cs typeface="Calibri" pitchFamily="34" charset="-120"/>
-              </a:rPr>
-              <a:t>Evidence-based choices</a:t>
-            </a:r>
-            <a:endParaRPr lang="en-US" sz="1700" dirty="0"/>
-          </a:p>
-        </p:txBody>
-      </p:sp>
-      <p:sp>
-        <p:nvSpPr>
-          <p:cNvPr id="12" name="Text 10"/>
-          <p:cNvSpPr/>
-          <p:nvPr/>
-        </p:nvSpPr>
-        <p:spPr>
-          <a:xfrm>
-            <a:off x="4480560" y="1965960"/>
-            <a:ext cx="3200400" cy="1737360"/>
-          </a:xfrm>
-          <a:prstGeom prst="rect">
-            <a:avLst/>
-          </a:prstGeom>
-          <a:noFill/>
-          <a:ln/>
-        </p:spPr>
-        <p:txBody>
-          <a:bodyPr wrap="square" rtlCol="0" anchor="t"/>
-          <a:lstStyle/>
-          <a:p>
-            <a:pPr indent="0" marL="0">
-              <a:buNone/>
-            </a:pPr>
-            <a:r>
-              <a:rPr lang="en-US" sz="1400" dirty="0">
-                <a:solidFill>
-                  <a:srgbClr val="14161C"/>
-                </a:solidFill>
-                <a:latin typeface="Calibri" pitchFamily="34" charset="0"/>
-                <a:ea typeface="Calibri" pitchFamily="34" charset="-122"/>
-                <a:cs typeface="Calibri" pitchFamily="34" charset="-120"/>
-              </a:rPr>
-              <a:t>Forecaster replaced after a backtest. Detector thresholds chosen from precision / recall. Limits reported.</a:t>
-            </a:r>
-            <a:endParaRPr lang="en-US" sz="1400" dirty="0"/>
-          </a:p>
-        </p:txBody>
-      </p:sp>
-      <p:sp>
-        <p:nvSpPr>
-          <p:cNvPr id="13" name="Shape 11"/>
-          <p:cNvSpPr/>
-          <p:nvPr/>
-        </p:nvSpPr>
-        <p:spPr>
-          <a:xfrm>
-            <a:off x="8046720" y="1463040"/>
-            <a:ext cx="3566160" cy="2331720"/>
-          </a:xfrm>
-          <a:prstGeom prst="roundRect">
-            <a:avLst>
-              <a:gd name="adj" fmla="val 3137"/>
-            </a:avLst>
-          </a:prstGeom>
-          <a:solidFill>
-            <a:srgbClr val="F5F6FA"/>
-          </a:solidFill>
-          <a:ln w="12700">
-            <a:solidFill>
-              <a:srgbClr val="D1D5DB"/>
-            </a:solidFill>
-            <a:prstDash val="solid"/>
-          </a:ln>
-        </p:spPr>
-      </p:sp>
-      <p:sp>
-        <p:nvSpPr>
-          <p:cNvPr id="14" name="Text 12"/>
-          <p:cNvSpPr/>
-          <p:nvPr/>
-        </p:nvSpPr>
-        <p:spPr>
-          <a:xfrm>
-            <a:off x="8229600" y="1572768"/>
-            <a:ext cx="3200400" cy="365760"/>
-          </a:xfrm>
-          <a:prstGeom prst="rect">
-            <a:avLst/>
-          </a:prstGeom>
-          <a:noFill/>
-          <a:ln/>
-        </p:spPr>
-        <p:txBody>
-          <a:bodyPr wrap="square" rtlCol="0" anchor="ctr"/>
-          <a:lstStyle/>
-          <a:p>
-            <a:pPr indent="0" marL="0">
-              <a:buNone/>
-            </a:pPr>
-            <a:r>
-              <a:rPr lang="en-US" sz="1700" b="1" dirty="0">
-                <a:solidFill>
-                  <a:srgbClr val="4C5CF0"/>
-                </a:solidFill>
-                <a:latin typeface="Calibri" pitchFamily="34" charset="0"/>
-                <a:ea typeface="Calibri" pitchFamily="34" charset="-122"/>
-                <a:cs typeface="Calibri" pitchFamily="34" charset="-120"/>
-              </a:rPr>
-              <a:t>Engineering + product in one</a:t>
-            </a:r>
-            <a:endParaRPr lang="en-US" sz="1700" dirty="0"/>
-          </a:p>
-        </p:txBody>
-      </p:sp>
-      <p:sp>
-        <p:nvSpPr>
-          <p:cNvPr id="15" name="Text 13"/>
-          <p:cNvSpPr/>
-          <p:nvPr/>
-        </p:nvSpPr>
-        <p:spPr>
-          <a:xfrm>
-            <a:off x="8229600" y="1965960"/>
-            <a:ext cx="3200400" cy="1737360"/>
-          </a:xfrm>
-          <a:prstGeom prst="rect">
-            <a:avLst/>
-          </a:prstGeom>
-          <a:noFill/>
-          <a:ln/>
-        </p:spPr>
-        <p:txBody>
-          <a:bodyPr wrap="square" rtlCol="0" anchor="t"/>
-          <a:lstStyle/>
-          <a:p>
-            <a:pPr indent="0" marL="0">
-              <a:buNone/>
-            </a:pPr>
-            <a:r>
-              <a:rPr lang="en-US" sz="1400" dirty="0">
-                <a:solidFill>
-                  <a:srgbClr val="14161C"/>
-                </a:solidFill>
-                <a:latin typeface="Calibri" pitchFamily="34" charset="0"/>
-                <a:ea typeface="Calibri" pitchFamily="34" charset="-122"/>
-                <a:cs typeface="Calibri" pitchFamily="34" charset="-120"/>
-              </a:rPr>
-              <a:t>The metrics program that planned the project ships inside the app as the Metrics tab.</a:t>
-            </a:r>
-            <a:endParaRPr lang="en-US" sz="1400" dirty="0"/>
-          </a:p>
-        </p:txBody>
-      </p:sp>
-      <p:sp>
-        <p:nvSpPr>
-          <p:cNvPr id="16" name="Shape 14"/>
-          <p:cNvSpPr/>
-          <p:nvPr/>
-        </p:nvSpPr>
-        <p:spPr>
-          <a:xfrm>
-            <a:off x="548640" y="3977640"/>
-            <a:ext cx="3566160" cy="2148840"/>
-          </a:xfrm>
-          <a:prstGeom prst="roundRect">
-            <a:avLst>
-              <a:gd name="adj" fmla="val 3404"/>
-            </a:avLst>
-          </a:prstGeom>
-          <a:solidFill>
-            <a:srgbClr val="F5F6FA"/>
-          </a:solidFill>
-          <a:ln w="12700">
-            <a:solidFill>
-              <a:srgbClr val="D1D5DB"/>
-            </a:solidFill>
-            <a:prstDash val="solid"/>
-          </a:ln>
-        </p:spPr>
-      </p:sp>
-      <p:sp>
-        <p:nvSpPr>
-          <p:cNvPr id="17" name="Text 15"/>
-          <p:cNvSpPr/>
-          <p:nvPr/>
-        </p:nvSpPr>
-        <p:spPr>
-          <a:xfrm>
-            <a:off x="731520" y="4087368"/>
-            <a:ext cx="3200400" cy="365760"/>
-          </a:xfrm>
-          <a:prstGeom prst="rect">
-            <a:avLst/>
-          </a:prstGeom>
-          <a:noFill/>
-          <a:ln/>
-        </p:spPr>
-        <p:txBody>
-          <a:bodyPr wrap="square" rtlCol="0" anchor="ctr"/>
-          <a:lstStyle/>
-          <a:p>
-            <a:pPr indent="0" marL="0">
-              <a:buNone/>
-            </a:pPr>
-            <a:r>
-              <a:rPr lang="en-US" sz="1700" b="1" dirty="0">
-                <a:solidFill>
-                  <a:srgbClr val="4C5CF0"/>
-                </a:solidFill>
-                <a:latin typeface="Calibri" pitchFamily="34" charset="0"/>
-                <a:ea typeface="Calibri" pitchFamily="34" charset="-122"/>
-                <a:cs typeface="Calibri" pitchFamily="34" charset="-120"/>
-              </a:rPr>
-              <a:t>Reliable on a free tier</a:t>
-            </a:r>
-            <a:endParaRPr lang="en-US" sz="1700" dirty="0"/>
-          </a:p>
-        </p:txBody>
-      </p:sp>
-      <p:sp>
-        <p:nvSpPr>
-          <p:cNvPr id="18" name="Text 16"/>
-          <p:cNvSpPr/>
-          <p:nvPr/>
-        </p:nvSpPr>
-        <p:spPr>
-          <a:xfrm>
-            <a:off x="731520" y="4480560"/>
-            <a:ext cx="3200400" cy="1554480"/>
-          </a:xfrm>
-          <a:prstGeom prst="rect">
-            <a:avLst/>
-          </a:prstGeom>
-          <a:noFill/>
-          <a:ln/>
-        </p:spPr>
-        <p:txBody>
-          <a:bodyPr wrap="square" rtlCol="0" anchor="t"/>
-          <a:lstStyle/>
-          <a:p>
-            <a:pPr indent="0" marL="0">
-              <a:buNone/>
-            </a:pPr>
-            <a:r>
-              <a:rPr lang="en-US" sz="1400" dirty="0">
-                <a:solidFill>
-                  <a:srgbClr val="14161C"/>
-                </a:solidFill>
-                <a:latin typeface="Calibri" pitchFamily="34" charset="0"/>
-                <a:ea typeface="Calibri" pitchFamily="34" charset="-122"/>
-                <a:cs typeface="Calibri" pitchFamily="34" charset="-120"/>
-              </a:rPr>
-              <a:t>Model fallback chain, retry, MongoDB response cache, clear “quota used up” message.</a:t>
-            </a:r>
-            <a:endParaRPr lang="en-US" sz="1400" dirty="0"/>
-          </a:p>
-        </p:txBody>
-      </p:sp>
-      <p:sp>
-        <p:nvSpPr>
-          <p:cNvPr id="19" name="Shape 17"/>
-          <p:cNvSpPr/>
-          <p:nvPr/>
-        </p:nvSpPr>
-        <p:spPr>
-          <a:xfrm>
-            <a:off x="4297680" y="3977640"/>
-            <a:ext cx="3566160" cy="2148840"/>
-          </a:xfrm>
-          <a:prstGeom prst="roundRect">
-            <a:avLst>
-              <a:gd name="adj" fmla="val 3404"/>
-            </a:avLst>
-          </a:prstGeom>
-          <a:solidFill>
-            <a:srgbClr val="F5F6FA"/>
-          </a:solidFill>
-          <a:ln w="12700">
-            <a:solidFill>
-              <a:srgbClr val="D1D5DB"/>
-            </a:solidFill>
-            <a:prstDash val="solid"/>
-          </a:ln>
-        </p:spPr>
-      </p:sp>
-      <p:sp>
-        <p:nvSpPr>
-          <p:cNvPr id="20" name="Text 18"/>
-          <p:cNvSpPr/>
-          <p:nvPr/>
-        </p:nvSpPr>
-        <p:spPr>
-          <a:xfrm>
-            <a:off x="4480560" y="4087368"/>
-            <a:ext cx="3200400" cy="365760"/>
-          </a:xfrm>
-          <a:prstGeom prst="rect">
-            <a:avLst/>
-          </a:prstGeom>
-          <a:noFill/>
-          <a:ln/>
-        </p:spPr>
-        <p:txBody>
-          <a:bodyPr wrap="square" rtlCol="0" anchor="ctr"/>
-          <a:lstStyle/>
-          <a:p>
-            <a:pPr indent="0" marL="0">
-              <a:buNone/>
-            </a:pPr>
-            <a:r>
-              <a:rPr lang="en-US" sz="1700" b="1" dirty="0">
-                <a:solidFill>
-                  <a:srgbClr val="4C5CF0"/>
-                </a:solidFill>
-                <a:latin typeface="Calibri" pitchFamily="34" charset="0"/>
-                <a:ea typeface="Calibri" pitchFamily="34" charset="-122"/>
-                <a:cs typeface="Calibri" pitchFamily="34" charset="-120"/>
-              </a:rPr>
-              <a:t>A reason to return daily</a:t>
-            </a:r>
-            <a:endParaRPr lang="en-US" sz="1700" dirty="0"/>
-          </a:p>
-        </p:txBody>
-      </p:sp>
-      <p:sp>
-        <p:nvSpPr>
-          <p:cNvPr id="21" name="Text 19"/>
-          <p:cNvSpPr/>
-          <p:nvPr/>
-        </p:nvSpPr>
-        <p:spPr>
-          <a:xfrm>
-            <a:off x="4480560" y="4480560"/>
-            <a:ext cx="3200400" cy="1554480"/>
-          </a:xfrm>
-          <a:prstGeom prst="rect">
-            <a:avLst/>
-          </a:prstGeom>
-          <a:noFill/>
-          <a:ln/>
-        </p:spPr>
-        <p:txBody>
-          <a:bodyPr wrap="square" rtlCol="0" anchor="t"/>
-          <a:lstStyle/>
-          <a:p>
-            <a:pPr indent="0" marL="0">
-              <a:buNone/>
-            </a:pPr>
-            <a:r>
-              <a:rPr lang="en-US" sz="1400" dirty="0">
-                <a:solidFill>
-                  <a:srgbClr val="14161C"/>
-                </a:solidFill>
-                <a:latin typeface="Calibri" pitchFamily="34" charset="0"/>
-                <a:ea typeface="Calibri" pitchFamily="34" charset="-122"/>
-                <a:cs typeface="Calibri" pitchFamily="34" charset="-120"/>
-              </a:rPr>
-              <a:t>Safe-to-spend, subscriptions, goal ETA, what-if, health score, Ask AI.</a:t>
-            </a:r>
-            <a:endParaRPr lang="en-US" sz="1400" dirty="0"/>
-          </a:p>
-        </p:txBody>
-      </p:sp>
-      <p:sp>
-        <p:nvSpPr>
-          <p:cNvPr id="22" name="Shape 20"/>
-          <p:cNvSpPr/>
-          <p:nvPr/>
-        </p:nvSpPr>
-        <p:spPr>
-          <a:xfrm>
-            <a:off x="8046720" y="3977640"/>
-            <a:ext cx="3566160" cy="2148840"/>
-          </a:xfrm>
-          <a:prstGeom prst="roundRect">
-            <a:avLst>
-              <a:gd name="adj" fmla="val 3404"/>
-            </a:avLst>
-          </a:prstGeom>
-          <a:solidFill>
-            <a:srgbClr val="F5F6FA"/>
-          </a:solidFill>
-          <a:ln w="12700">
-            <a:solidFill>
-              <a:srgbClr val="D1D5DB"/>
-            </a:solidFill>
-            <a:prstDash val="solid"/>
-          </a:ln>
-        </p:spPr>
-      </p:sp>
-      <p:sp>
-        <p:nvSpPr>
-          <p:cNvPr id="23" name="Text 21"/>
-          <p:cNvSpPr/>
-          <p:nvPr/>
-        </p:nvSpPr>
-        <p:spPr>
-          <a:xfrm>
-            <a:off x="8229600" y="4087368"/>
-            <a:ext cx="3200400" cy="365760"/>
-          </a:xfrm>
-          <a:prstGeom prst="rect">
-            <a:avLst/>
-          </a:prstGeom>
-          <a:noFill/>
-          <a:ln/>
-        </p:spPr>
-        <p:txBody>
-          <a:bodyPr wrap="square" rtlCol="0" anchor="ctr"/>
-          <a:lstStyle/>
-          <a:p>
-            <a:pPr indent="0" marL="0">
-              <a:buNone/>
-            </a:pPr>
-            <a:r>
-              <a:rPr lang="en-US" sz="1700" b="1" dirty="0">
-                <a:solidFill>
-                  <a:srgbClr val="4C5CF0"/>
-                </a:solidFill>
-                <a:latin typeface="Calibri" pitchFamily="34" charset="0"/>
-                <a:ea typeface="Calibri" pitchFamily="34" charset="-122"/>
-                <a:cs typeface="Calibri" pitchFamily="34" charset="-120"/>
-              </a:rPr>
-              <a:t>Privacy-aware</a:t>
-            </a:r>
-            <a:endParaRPr lang="en-US" sz="1700" dirty="0"/>
-          </a:p>
-        </p:txBody>
-      </p:sp>
-      <p:sp>
-        <p:nvSpPr>
-          <p:cNvPr id="24" name="Text 22"/>
-          <p:cNvSpPr/>
-          <p:nvPr/>
-        </p:nvSpPr>
-        <p:spPr>
-          <a:xfrm>
-            <a:off x="8229600" y="4480560"/>
-            <a:ext cx="3200400" cy="1554480"/>
-          </a:xfrm>
-          <a:prstGeom prst="rect">
-            <a:avLst/>
-          </a:prstGeom>
-          <a:noFill/>
-          <a:ln/>
-        </p:spPr>
-        <p:txBody>
-          <a:bodyPr wrap="square" rtlCol="0" anchor="t"/>
-          <a:lstStyle/>
-          <a:p>
-            <a:pPr indent="0" marL="0">
-              <a:buNone/>
-            </a:pPr>
-            <a:r>
-              <a:rPr lang="en-US" sz="1400" dirty="0">
-                <a:solidFill>
-                  <a:srgbClr val="14161C"/>
-                </a:solidFill>
-                <a:latin typeface="Calibri" pitchFamily="34" charset="0"/>
-                <a:ea typeface="Calibri" pitchFamily="34" charset="-122"/>
-                <a:cs typeface="Calibri" pitchFamily="34" charset="-120"/>
-              </a:rPr>
-              <a:t>Bill images never stored; Ask AI sees only the user's own summary; secrets kept out of the repo.</a:t>
-            </a:r>
-            <a:endParaRPr lang="en-US" sz="1400" dirty="0"/>
+              <a:t>I-MR chart flags week 12.  Complexity ↔ defect density positive under Pearson, Spearman and Kendall.  P(High project risk): 28% baseline → 55% worst case → 27% with team upskilling.</a:t>
+            </a:r>
+            <a:endParaRPr lang="en-US" sz="1600" dirty="0"/>
           </a:p>
         </p:txBody>
       </p:sp>
@@ -8143,7 +7791,7 @@
                 <a:ea typeface="Calibri" pitchFamily="34" charset="-122"/>
                 <a:cs typeface="Calibri" pitchFamily="34" charset="-120"/>
               </a:rPr>
-              <a:t>CONCLUSION AND FUTURE WORK</a:t>
+              <a:t>NOVELTY AND INNOVATION / JUSTIFICATION</a:t>
             </a:r>
             <a:endParaRPr lang="en-US" sz="1200" dirty="0"/>
           </a:p>
@@ -8182,7 +7830,7 @@
                 <a:ea typeface="Calibri" pitchFamily="34" charset="-122"/>
                 <a:cs typeface="Calibri" pitchFamily="34" charset="-120"/>
               </a:rPr>
-              <a:t>Conclusion and future work</a:t>
+              <a:t>Why this is different — and why it is justified</a:t>
             </a:r>
             <a:endParaRPr lang="en-US" sz="3000" dirty="0"/>
           </a:p>
@@ -8222,6 +7870,849 @@
                 <a:cs typeface="Calibri" pitchFamily="34" charset="-120"/>
               </a:rPr>
               <a:t>17</a:t>
+            </a:r>
+            <a:endParaRPr lang="en-US" sz="1100" dirty="0"/>
+          </a:p>
+        </p:txBody>
+      </p:sp>
+      <p:sp>
+        <p:nvSpPr>
+          <p:cNvPr id="6" name="Text 4"/>
+          <p:cNvSpPr/>
+          <p:nvPr/>
+        </p:nvSpPr>
+        <p:spPr>
+          <a:xfrm>
+            <a:off x="548640" y="6400800"/>
+            <a:ext cx="2743200" cy="274320"/>
+          </a:xfrm>
+          <a:prstGeom prst="rect">
+            <a:avLst/>
+          </a:prstGeom>
+          <a:noFill/>
+          <a:ln/>
+        </p:spPr>
+        <p:txBody>
+          <a:bodyPr wrap="square" rtlCol="0" anchor="ctr"/>
+          <a:lstStyle/>
+          <a:p>
+            <a:pPr indent="0" marL="0">
+              <a:buNone/>
+            </a:pPr>
+            <a:r>
+              <a:rPr lang="en-US" sz="1100" dirty="0">
+                <a:solidFill>
+                  <a:srgbClr val="4B5563"/>
+                </a:solidFill>
+                <a:latin typeface="Calibri" pitchFamily="34" charset="0"/>
+                <a:ea typeface="Calibri" pitchFamily="34" charset="-122"/>
+                <a:cs typeface="Calibri" pitchFamily="34" charset="-120"/>
+              </a:rPr>
+              <a:t>Wealthline</a:t>
+            </a:r>
+            <a:endParaRPr lang="en-US" sz="1100" dirty="0"/>
+          </a:p>
+        </p:txBody>
+      </p:sp>
+      <p:sp>
+        <p:nvSpPr>
+          <p:cNvPr id="7" name="Shape 5"/>
+          <p:cNvSpPr/>
+          <p:nvPr/>
+        </p:nvSpPr>
+        <p:spPr>
+          <a:xfrm>
+            <a:off x="548640" y="1463040"/>
+            <a:ext cx="3566160" cy="2331720"/>
+          </a:xfrm>
+          <a:prstGeom prst="roundRect">
+            <a:avLst>
+              <a:gd name="adj" fmla="val 3137"/>
+            </a:avLst>
+          </a:prstGeom>
+          <a:solidFill>
+            <a:srgbClr val="F5F6FA"/>
+          </a:solidFill>
+          <a:ln w="12700">
+            <a:solidFill>
+              <a:srgbClr val="D1D5DB"/>
+            </a:solidFill>
+            <a:prstDash val="solid"/>
+          </a:ln>
+        </p:spPr>
+      </p:sp>
+      <p:sp>
+        <p:nvSpPr>
+          <p:cNvPr id="8" name="Text 6"/>
+          <p:cNvSpPr/>
+          <p:nvPr/>
+        </p:nvSpPr>
+        <p:spPr>
+          <a:xfrm>
+            <a:off x="731520" y="1572768"/>
+            <a:ext cx="3200400" cy="365760"/>
+          </a:xfrm>
+          <a:prstGeom prst="rect">
+            <a:avLst/>
+          </a:prstGeom>
+          <a:noFill/>
+          <a:ln/>
+        </p:spPr>
+        <p:txBody>
+          <a:bodyPr wrap="square" rtlCol="0" anchor="ctr"/>
+          <a:lstStyle/>
+          <a:p>
+            <a:pPr indent="0" marL="0">
+              <a:buNone/>
+            </a:pPr>
+            <a:r>
+              <a:rPr lang="en-US" sz="1700" b="1" dirty="0">
+                <a:solidFill>
+                  <a:srgbClr val="4C5CF0"/>
+                </a:solidFill>
+                <a:latin typeface="Calibri" pitchFamily="34" charset="0"/>
+                <a:ea typeface="Calibri" pitchFamily="34" charset="-122"/>
+                <a:cs typeface="Calibri" pitchFamily="34" charset="-120"/>
+              </a:rPr>
+              <a:t>AI proposes, code verifies</a:t>
+            </a:r>
+            <a:endParaRPr lang="en-US" sz="1700" dirty="0"/>
+          </a:p>
+        </p:txBody>
+      </p:sp>
+      <p:sp>
+        <p:nvSpPr>
+          <p:cNvPr id="9" name="Text 7"/>
+          <p:cNvSpPr/>
+          <p:nvPr/>
+        </p:nvSpPr>
+        <p:spPr>
+          <a:xfrm>
+            <a:off x="731520" y="1965960"/>
+            <a:ext cx="3200400" cy="1737360"/>
+          </a:xfrm>
+          <a:prstGeom prst="rect">
+            <a:avLst/>
+          </a:prstGeom>
+          <a:noFill/>
+          <a:ln/>
+        </p:spPr>
+        <p:txBody>
+          <a:bodyPr wrap="square" rtlCol="0" anchor="t"/>
+          <a:lstStyle/>
+          <a:p>
+            <a:pPr indent="0" marL="0">
+              <a:buNone/>
+            </a:pPr>
+            <a:r>
+              <a:rPr lang="en-US" sz="1400" dirty="0">
+                <a:solidFill>
+                  <a:srgbClr val="14161C"/>
+                </a:solidFill>
+                <a:latin typeface="Calibri" pitchFamily="34" charset="0"/>
+                <a:ea typeface="Calibri" pitchFamily="34" charset="-122"/>
+                <a:cs typeface="Calibri" pitchFamily="34" charset="-120"/>
+              </a:rPr>
+              <a:t>The model only reads the bill. Budget impact, duplicate and date checks are deterministic server code; the user confirms.</a:t>
+            </a:r>
+            <a:endParaRPr lang="en-US" sz="1400" dirty="0"/>
+          </a:p>
+        </p:txBody>
+      </p:sp>
+      <p:sp>
+        <p:nvSpPr>
+          <p:cNvPr id="10" name="Shape 8"/>
+          <p:cNvSpPr/>
+          <p:nvPr/>
+        </p:nvSpPr>
+        <p:spPr>
+          <a:xfrm>
+            <a:off x="4297680" y="1463040"/>
+            <a:ext cx="3566160" cy="2331720"/>
+          </a:xfrm>
+          <a:prstGeom prst="roundRect">
+            <a:avLst>
+              <a:gd name="adj" fmla="val 3137"/>
+            </a:avLst>
+          </a:prstGeom>
+          <a:solidFill>
+            <a:srgbClr val="F5F6FA"/>
+          </a:solidFill>
+          <a:ln w="12700">
+            <a:solidFill>
+              <a:srgbClr val="D1D5DB"/>
+            </a:solidFill>
+            <a:prstDash val="solid"/>
+          </a:ln>
+        </p:spPr>
+      </p:sp>
+      <p:sp>
+        <p:nvSpPr>
+          <p:cNvPr id="11" name="Text 9"/>
+          <p:cNvSpPr/>
+          <p:nvPr/>
+        </p:nvSpPr>
+        <p:spPr>
+          <a:xfrm>
+            <a:off x="4480560" y="1572768"/>
+            <a:ext cx="3200400" cy="365760"/>
+          </a:xfrm>
+          <a:prstGeom prst="rect">
+            <a:avLst/>
+          </a:prstGeom>
+          <a:noFill/>
+          <a:ln/>
+        </p:spPr>
+        <p:txBody>
+          <a:bodyPr wrap="square" rtlCol="0" anchor="ctr"/>
+          <a:lstStyle/>
+          <a:p>
+            <a:pPr indent="0" marL="0">
+              <a:buNone/>
+            </a:pPr>
+            <a:r>
+              <a:rPr lang="en-US" sz="1700" b="1" dirty="0">
+                <a:solidFill>
+                  <a:srgbClr val="4C5CF0"/>
+                </a:solidFill>
+                <a:latin typeface="Calibri" pitchFamily="34" charset="0"/>
+                <a:ea typeface="Calibri" pitchFamily="34" charset="-122"/>
+                <a:cs typeface="Calibri" pitchFamily="34" charset="-120"/>
+              </a:rPr>
+              <a:t>Evidence-based choices</a:t>
+            </a:r>
+            <a:endParaRPr lang="en-US" sz="1700" dirty="0"/>
+          </a:p>
+        </p:txBody>
+      </p:sp>
+      <p:sp>
+        <p:nvSpPr>
+          <p:cNvPr id="12" name="Text 10"/>
+          <p:cNvSpPr/>
+          <p:nvPr/>
+        </p:nvSpPr>
+        <p:spPr>
+          <a:xfrm>
+            <a:off x="4480560" y="1965960"/>
+            <a:ext cx="3200400" cy="1737360"/>
+          </a:xfrm>
+          <a:prstGeom prst="rect">
+            <a:avLst/>
+          </a:prstGeom>
+          <a:noFill/>
+          <a:ln/>
+        </p:spPr>
+        <p:txBody>
+          <a:bodyPr wrap="square" rtlCol="0" anchor="t"/>
+          <a:lstStyle/>
+          <a:p>
+            <a:pPr indent="0" marL="0">
+              <a:buNone/>
+            </a:pPr>
+            <a:r>
+              <a:rPr lang="en-US" sz="1400" dirty="0">
+                <a:solidFill>
+                  <a:srgbClr val="14161C"/>
+                </a:solidFill>
+                <a:latin typeface="Calibri" pitchFamily="34" charset="0"/>
+                <a:ea typeface="Calibri" pitchFamily="34" charset="-122"/>
+                <a:cs typeface="Calibri" pitchFamily="34" charset="-120"/>
+              </a:rPr>
+              <a:t>Forecaster replaced after a backtest. Detector thresholds chosen from precision / recall. Limits reported.</a:t>
+            </a:r>
+            <a:endParaRPr lang="en-US" sz="1400" dirty="0"/>
+          </a:p>
+        </p:txBody>
+      </p:sp>
+      <p:sp>
+        <p:nvSpPr>
+          <p:cNvPr id="13" name="Shape 11"/>
+          <p:cNvSpPr/>
+          <p:nvPr/>
+        </p:nvSpPr>
+        <p:spPr>
+          <a:xfrm>
+            <a:off x="8046720" y="1463040"/>
+            <a:ext cx="3566160" cy="2331720"/>
+          </a:xfrm>
+          <a:prstGeom prst="roundRect">
+            <a:avLst>
+              <a:gd name="adj" fmla="val 3137"/>
+            </a:avLst>
+          </a:prstGeom>
+          <a:solidFill>
+            <a:srgbClr val="F5F6FA"/>
+          </a:solidFill>
+          <a:ln w="12700">
+            <a:solidFill>
+              <a:srgbClr val="D1D5DB"/>
+            </a:solidFill>
+            <a:prstDash val="solid"/>
+          </a:ln>
+        </p:spPr>
+      </p:sp>
+      <p:sp>
+        <p:nvSpPr>
+          <p:cNvPr id="14" name="Text 12"/>
+          <p:cNvSpPr/>
+          <p:nvPr/>
+        </p:nvSpPr>
+        <p:spPr>
+          <a:xfrm>
+            <a:off x="8229600" y="1572768"/>
+            <a:ext cx="3200400" cy="365760"/>
+          </a:xfrm>
+          <a:prstGeom prst="rect">
+            <a:avLst/>
+          </a:prstGeom>
+          <a:noFill/>
+          <a:ln/>
+        </p:spPr>
+        <p:txBody>
+          <a:bodyPr wrap="square" rtlCol="0" anchor="ctr"/>
+          <a:lstStyle/>
+          <a:p>
+            <a:pPr indent="0" marL="0">
+              <a:buNone/>
+            </a:pPr>
+            <a:r>
+              <a:rPr lang="en-US" sz="1700" b="1" dirty="0">
+                <a:solidFill>
+                  <a:srgbClr val="4C5CF0"/>
+                </a:solidFill>
+                <a:latin typeface="Calibri" pitchFamily="34" charset="0"/>
+                <a:ea typeface="Calibri" pitchFamily="34" charset="-122"/>
+                <a:cs typeface="Calibri" pitchFamily="34" charset="-120"/>
+              </a:rPr>
+              <a:t>Engineering + product in one</a:t>
+            </a:r>
+            <a:endParaRPr lang="en-US" sz="1700" dirty="0"/>
+          </a:p>
+        </p:txBody>
+      </p:sp>
+      <p:sp>
+        <p:nvSpPr>
+          <p:cNvPr id="15" name="Text 13"/>
+          <p:cNvSpPr/>
+          <p:nvPr/>
+        </p:nvSpPr>
+        <p:spPr>
+          <a:xfrm>
+            <a:off x="8229600" y="1965960"/>
+            <a:ext cx="3200400" cy="1737360"/>
+          </a:xfrm>
+          <a:prstGeom prst="rect">
+            <a:avLst/>
+          </a:prstGeom>
+          <a:noFill/>
+          <a:ln/>
+        </p:spPr>
+        <p:txBody>
+          <a:bodyPr wrap="square" rtlCol="0" anchor="t"/>
+          <a:lstStyle/>
+          <a:p>
+            <a:pPr indent="0" marL="0">
+              <a:buNone/>
+            </a:pPr>
+            <a:r>
+              <a:rPr lang="en-US" sz="1400" dirty="0">
+                <a:solidFill>
+                  <a:srgbClr val="14161C"/>
+                </a:solidFill>
+                <a:latin typeface="Calibri" pitchFamily="34" charset="0"/>
+                <a:ea typeface="Calibri" pitchFamily="34" charset="-122"/>
+                <a:cs typeface="Calibri" pitchFamily="34" charset="-120"/>
+              </a:rPr>
+              <a:t>The metrics program that planned the project ships inside the app as the Metrics tab.</a:t>
+            </a:r>
+            <a:endParaRPr lang="en-US" sz="1400" dirty="0"/>
+          </a:p>
+        </p:txBody>
+      </p:sp>
+      <p:sp>
+        <p:nvSpPr>
+          <p:cNvPr id="16" name="Shape 14"/>
+          <p:cNvSpPr/>
+          <p:nvPr/>
+        </p:nvSpPr>
+        <p:spPr>
+          <a:xfrm>
+            <a:off x="548640" y="3977640"/>
+            <a:ext cx="3566160" cy="2148840"/>
+          </a:xfrm>
+          <a:prstGeom prst="roundRect">
+            <a:avLst>
+              <a:gd name="adj" fmla="val 3404"/>
+            </a:avLst>
+          </a:prstGeom>
+          <a:solidFill>
+            <a:srgbClr val="F5F6FA"/>
+          </a:solidFill>
+          <a:ln w="12700">
+            <a:solidFill>
+              <a:srgbClr val="D1D5DB"/>
+            </a:solidFill>
+            <a:prstDash val="solid"/>
+          </a:ln>
+        </p:spPr>
+      </p:sp>
+      <p:sp>
+        <p:nvSpPr>
+          <p:cNvPr id="17" name="Text 15"/>
+          <p:cNvSpPr/>
+          <p:nvPr/>
+        </p:nvSpPr>
+        <p:spPr>
+          <a:xfrm>
+            <a:off x="731520" y="4087368"/>
+            <a:ext cx="3200400" cy="365760"/>
+          </a:xfrm>
+          <a:prstGeom prst="rect">
+            <a:avLst/>
+          </a:prstGeom>
+          <a:noFill/>
+          <a:ln/>
+        </p:spPr>
+        <p:txBody>
+          <a:bodyPr wrap="square" rtlCol="0" anchor="ctr"/>
+          <a:lstStyle/>
+          <a:p>
+            <a:pPr indent="0" marL="0">
+              <a:buNone/>
+            </a:pPr>
+            <a:r>
+              <a:rPr lang="en-US" sz="1700" b="1" dirty="0">
+                <a:solidFill>
+                  <a:srgbClr val="4C5CF0"/>
+                </a:solidFill>
+                <a:latin typeface="Calibri" pitchFamily="34" charset="0"/>
+                <a:ea typeface="Calibri" pitchFamily="34" charset="-122"/>
+                <a:cs typeface="Calibri" pitchFamily="34" charset="-120"/>
+              </a:rPr>
+              <a:t>Reliable on a free tier</a:t>
+            </a:r>
+            <a:endParaRPr lang="en-US" sz="1700" dirty="0"/>
+          </a:p>
+        </p:txBody>
+      </p:sp>
+      <p:sp>
+        <p:nvSpPr>
+          <p:cNvPr id="18" name="Text 16"/>
+          <p:cNvSpPr/>
+          <p:nvPr/>
+        </p:nvSpPr>
+        <p:spPr>
+          <a:xfrm>
+            <a:off x="731520" y="4480560"/>
+            <a:ext cx="3200400" cy="1554480"/>
+          </a:xfrm>
+          <a:prstGeom prst="rect">
+            <a:avLst/>
+          </a:prstGeom>
+          <a:noFill/>
+          <a:ln/>
+        </p:spPr>
+        <p:txBody>
+          <a:bodyPr wrap="square" rtlCol="0" anchor="t"/>
+          <a:lstStyle/>
+          <a:p>
+            <a:pPr indent="0" marL="0">
+              <a:buNone/>
+            </a:pPr>
+            <a:r>
+              <a:rPr lang="en-US" sz="1400" dirty="0">
+                <a:solidFill>
+                  <a:srgbClr val="14161C"/>
+                </a:solidFill>
+                <a:latin typeface="Calibri" pitchFamily="34" charset="0"/>
+                <a:ea typeface="Calibri" pitchFamily="34" charset="-122"/>
+                <a:cs typeface="Calibri" pitchFamily="34" charset="-120"/>
+              </a:rPr>
+              <a:t>Model fallback chain, retry, MongoDB response cache, clear “quota used up” message.</a:t>
+            </a:r>
+            <a:endParaRPr lang="en-US" sz="1400" dirty="0"/>
+          </a:p>
+        </p:txBody>
+      </p:sp>
+      <p:sp>
+        <p:nvSpPr>
+          <p:cNvPr id="19" name="Shape 17"/>
+          <p:cNvSpPr/>
+          <p:nvPr/>
+        </p:nvSpPr>
+        <p:spPr>
+          <a:xfrm>
+            <a:off x="4297680" y="3977640"/>
+            <a:ext cx="3566160" cy="2148840"/>
+          </a:xfrm>
+          <a:prstGeom prst="roundRect">
+            <a:avLst>
+              <a:gd name="adj" fmla="val 3404"/>
+            </a:avLst>
+          </a:prstGeom>
+          <a:solidFill>
+            <a:srgbClr val="F5F6FA"/>
+          </a:solidFill>
+          <a:ln w="12700">
+            <a:solidFill>
+              <a:srgbClr val="D1D5DB"/>
+            </a:solidFill>
+            <a:prstDash val="solid"/>
+          </a:ln>
+        </p:spPr>
+      </p:sp>
+      <p:sp>
+        <p:nvSpPr>
+          <p:cNvPr id="20" name="Text 18"/>
+          <p:cNvSpPr/>
+          <p:nvPr/>
+        </p:nvSpPr>
+        <p:spPr>
+          <a:xfrm>
+            <a:off x="4480560" y="4087368"/>
+            <a:ext cx="3200400" cy="365760"/>
+          </a:xfrm>
+          <a:prstGeom prst="rect">
+            <a:avLst/>
+          </a:prstGeom>
+          <a:noFill/>
+          <a:ln/>
+        </p:spPr>
+        <p:txBody>
+          <a:bodyPr wrap="square" rtlCol="0" anchor="ctr"/>
+          <a:lstStyle/>
+          <a:p>
+            <a:pPr indent="0" marL="0">
+              <a:buNone/>
+            </a:pPr>
+            <a:r>
+              <a:rPr lang="en-US" sz="1700" b="1" dirty="0">
+                <a:solidFill>
+                  <a:srgbClr val="4C5CF0"/>
+                </a:solidFill>
+                <a:latin typeface="Calibri" pitchFamily="34" charset="0"/>
+                <a:ea typeface="Calibri" pitchFamily="34" charset="-122"/>
+                <a:cs typeface="Calibri" pitchFamily="34" charset="-120"/>
+              </a:rPr>
+              <a:t>A reason to return daily</a:t>
+            </a:r>
+            <a:endParaRPr lang="en-US" sz="1700" dirty="0"/>
+          </a:p>
+        </p:txBody>
+      </p:sp>
+      <p:sp>
+        <p:nvSpPr>
+          <p:cNvPr id="21" name="Text 19"/>
+          <p:cNvSpPr/>
+          <p:nvPr/>
+        </p:nvSpPr>
+        <p:spPr>
+          <a:xfrm>
+            <a:off x="4480560" y="4480560"/>
+            <a:ext cx="3200400" cy="1554480"/>
+          </a:xfrm>
+          <a:prstGeom prst="rect">
+            <a:avLst/>
+          </a:prstGeom>
+          <a:noFill/>
+          <a:ln/>
+        </p:spPr>
+        <p:txBody>
+          <a:bodyPr wrap="square" rtlCol="0" anchor="t"/>
+          <a:lstStyle/>
+          <a:p>
+            <a:pPr indent="0" marL="0">
+              <a:buNone/>
+            </a:pPr>
+            <a:r>
+              <a:rPr lang="en-US" sz="1400" dirty="0">
+                <a:solidFill>
+                  <a:srgbClr val="14161C"/>
+                </a:solidFill>
+                <a:latin typeface="Calibri" pitchFamily="34" charset="0"/>
+                <a:ea typeface="Calibri" pitchFamily="34" charset="-122"/>
+                <a:cs typeface="Calibri" pitchFamily="34" charset="-120"/>
+              </a:rPr>
+              <a:t>Safe-to-spend, subscriptions, goal ETA, what-if, health score, Ask AI.</a:t>
+            </a:r>
+            <a:endParaRPr lang="en-US" sz="1400" dirty="0"/>
+          </a:p>
+        </p:txBody>
+      </p:sp>
+      <p:sp>
+        <p:nvSpPr>
+          <p:cNvPr id="22" name="Shape 20"/>
+          <p:cNvSpPr/>
+          <p:nvPr/>
+        </p:nvSpPr>
+        <p:spPr>
+          <a:xfrm>
+            <a:off x="8046720" y="3977640"/>
+            <a:ext cx="3566160" cy="2148840"/>
+          </a:xfrm>
+          <a:prstGeom prst="roundRect">
+            <a:avLst>
+              <a:gd name="adj" fmla="val 3404"/>
+            </a:avLst>
+          </a:prstGeom>
+          <a:solidFill>
+            <a:srgbClr val="F5F6FA"/>
+          </a:solidFill>
+          <a:ln w="12700">
+            <a:solidFill>
+              <a:srgbClr val="D1D5DB"/>
+            </a:solidFill>
+            <a:prstDash val="solid"/>
+          </a:ln>
+        </p:spPr>
+      </p:sp>
+      <p:sp>
+        <p:nvSpPr>
+          <p:cNvPr id="23" name="Text 21"/>
+          <p:cNvSpPr/>
+          <p:nvPr/>
+        </p:nvSpPr>
+        <p:spPr>
+          <a:xfrm>
+            <a:off x="8229600" y="4087368"/>
+            <a:ext cx="3200400" cy="365760"/>
+          </a:xfrm>
+          <a:prstGeom prst="rect">
+            <a:avLst/>
+          </a:prstGeom>
+          <a:noFill/>
+          <a:ln/>
+        </p:spPr>
+        <p:txBody>
+          <a:bodyPr wrap="square" rtlCol="0" anchor="ctr"/>
+          <a:lstStyle/>
+          <a:p>
+            <a:pPr indent="0" marL="0">
+              <a:buNone/>
+            </a:pPr>
+            <a:r>
+              <a:rPr lang="en-US" sz="1700" b="1" dirty="0">
+                <a:solidFill>
+                  <a:srgbClr val="4C5CF0"/>
+                </a:solidFill>
+                <a:latin typeface="Calibri" pitchFamily="34" charset="0"/>
+                <a:ea typeface="Calibri" pitchFamily="34" charset="-122"/>
+                <a:cs typeface="Calibri" pitchFamily="34" charset="-120"/>
+              </a:rPr>
+              <a:t>Privacy-aware</a:t>
+            </a:r>
+            <a:endParaRPr lang="en-US" sz="1700" dirty="0"/>
+          </a:p>
+        </p:txBody>
+      </p:sp>
+      <p:sp>
+        <p:nvSpPr>
+          <p:cNvPr id="24" name="Text 22"/>
+          <p:cNvSpPr/>
+          <p:nvPr/>
+        </p:nvSpPr>
+        <p:spPr>
+          <a:xfrm>
+            <a:off x="8229600" y="4480560"/>
+            <a:ext cx="3200400" cy="1554480"/>
+          </a:xfrm>
+          <a:prstGeom prst="rect">
+            <a:avLst/>
+          </a:prstGeom>
+          <a:noFill/>
+          <a:ln/>
+        </p:spPr>
+        <p:txBody>
+          <a:bodyPr wrap="square" rtlCol="0" anchor="t"/>
+          <a:lstStyle/>
+          <a:p>
+            <a:pPr indent="0" marL="0">
+              <a:buNone/>
+            </a:pPr>
+            <a:r>
+              <a:rPr lang="en-US" sz="1400" dirty="0">
+                <a:solidFill>
+                  <a:srgbClr val="14161C"/>
+                </a:solidFill>
+                <a:latin typeface="Calibri" pitchFamily="34" charset="0"/>
+                <a:ea typeface="Calibri" pitchFamily="34" charset="-122"/>
+                <a:cs typeface="Calibri" pitchFamily="34" charset="-120"/>
+              </a:rPr>
+              <a:t>Bill images never stored; Ask AI sees only the user's own summary; secrets kept out of the repo.</a:t>
+            </a:r>
+            <a:endParaRPr lang="en-US" sz="1400" dirty="0"/>
+          </a:p>
+        </p:txBody>
+      </p:sp>
+    </p:spTree>
+  </p:cSld>
+  <p:clrMapOvr>
+    <a:masterClrMapping/>
+  </p:clrMapOvr>
+</p:sld>
+</file>
+
+<file path=ppt/slides/slide18.xml><?xml version="1.0" encoding="utf-8"?>
+<p:sld xmlns:a="http://schemas.openxmlformats.org/drawingml/2006/main" xmlns:r="http://schemas.openxmlformats.org/officeDocument/2006/relationships" xmlns:p="http://schemas.openxmlformats.org/presentationml/2006/main">
+  <p:cSld name="Slide 18">
+    <p:bg>
+      <p:bgPr>
+        <a:solidFill>
+          <a:srgbClr val="FFFFFF"/>
+        </a:solidFill>
+      </p:bgPr>
+    </p:bg>
+    <p:spTree>
+      <p:nvGrpSpPr>
+        <p:cNvPr id="1" name=""/>
+        <p:cNvGrpSpPr/>
+        <p:nvPr/>
+      </p:nvGrpSpPr>
+      <p:grpSpPr>
+        <a:xfrm>
+          <a:off x="0" y="0"/>
+          <a:ext cx="0" cy="0"/>
+          <a:chOff x="0" y="0"/>
+          <a:chExt cx="0" cy="0"/>
+        </a:xfrm>
+      </p:grpSpPr>
+      <p:sp>
+        <p:nvSpPr>
+          <p:cNvPr id="2" name="Shape 0"/>
+          <p:cNvSpPr/>
+          <p:nvPr/>
+        </p:nvSpPr>
+        <p:spPr>
+          <a:xfrm>
+            <a:off x="0" y="0"/>
+            <a:ext cx="164592" cy="6858000"/>
+          </a:xfrm>
+          <a:prstGeom prst="rect">
+            <a:avLst/>
+          </a:prstGeom>
+          <a:solidFill>
+            <a:srgbClr val="4C5CF0"/>
+          </a:solidFill>
+          <a:ln w="12700">
+            <a:solidFill>
+              <a:srgbClr val="4C5CF0"/>
+            </a:solidFill>
+            <a:prstDash val="solid"/>
+          </a:ln>
+        </p:spPr>
+      </p:sp>
+      <p:sp>
+        <p:nvSpPr>
+          <p:cNvPr id="3" name="Text 1"/>
+          <p:cNvSpPr/>
+          <p:nvPr/>
+        </p:nvSpPr>
+        <p:spPr>
+          <a:xfrm>
+            <a:off x="548640" y="274320"/>
+            <a:ext cx="8229600" cy="274320"/>
+          </a:xfrm>
+          <a:prstGeom prst="rect">
+            <a:avLst/>
+          </a:prstGeom>
+          <a:noFill/>
+          <a:ln/>
+        </p:spPr>
+        <p:txBody>
+          <a:bodyPr wrap="square" rtlCol="0" anchor="ctr"/>
+          <a:lstStyle/>
+          <a:p>
+            <a:pPr indent="0" marL="0">
+              <a:buNone/>
+            </a:pPr>
+            <a:r>
+              <a:rPr lang="en-US" sz="1200" b="1" spc="200" kern="0" dirty="0">
+                <a:solidFill>
+                  <a:srgbClr val="4C5CF0"/>
+                </a:solidFill>
+                <a:latin typeface="Calibri" pitchFamily="34" charset="0"/>
+                <a:ea typeface="Calibri" pitchFamily="34" charset="-122"/>
+                <a:cs typeface="Calibri" pitchFamily="34" charset="-120"/>
+              </a:rPr>
+              <a:t>CONCLUSION AND FUTURE WORK</a:t>
+            </a:r>
+            <a:endParaRPr lang="en-US" sz="1200" dirty="0"/>
+          </a:p>
+        </p:txBody>
+      </p:sp>
+      <p:sp>
+        <p:nvSpPr>
+          <p:cNvPr id="4" name="Text 2"/>
+          <p:cNvSpPr/>
+          <p:nvPr/>
+        </p:nvSpPr>
+        <p:spPr>
+          <a:xfrm>
+            <a:off x="548640" y="530352"/>
+            <a:ext cx="11155680" cy="731520"/>
+          </a:xfrm>
+          <a:prstGeom prst="rect">
+            <a:avLst/>
+          </a:prstGeom>
+          <a:noFill/>
+          <a:ln/>
+        </p:spPr>
+        <p:txBody>
+          <a:bodyPr wrap="square" rtlCol="0" anchor="ctr"/>
+          <a:lstStyle/>
+          <a:p>
+            <a:pPr indent="0" marL="0">
+              <a:buNone/>
+            </a:pPr>
+            <a:r>
+              <a:rPr lang="en-US" sz="3000" b="1" dirty="0">
+                <a:solidFill>
+                  <a:srgbClr val="14161C"/>
+                </a:solidFill>
+                <a:latin typeface="Calibri" pitchFamily="34" charset="0"/>
+                <a:ea typeface="Calibri" pitchFamily="34" charset="-122"/>
+                <a:cs typeface="Calibri" pitchFamily="34" charset="-120"/>
+              </a:rPr>
+              <a:t>Conclusion and future work</a:t>
+            </a:r>
+            <a:endParaRPr lang="en-US" sz="3000" dirty="0"/>
+          </a:p>
+        </p:txBody>
+      </p:sp>
+      <p:sp>
+        <p:nvSpPr>
+          <p:cNvPr id="5" name="Text 3"/>
+          <p:cNvSpPr/>
+          <p:nvPr/>
+        </p:nvSpPr>
+        <p:spPr>
+          <a:xfrm>
+            <a:off x="11338560" y="6400800"/>
+            <a:ext cx="548640" cy="274320"/>
+          </a:xfrm>
+          <a:prstGeom prst="rect">
+            <a:avLst/>
+          </a:prstGeom>
+          <a:noFill/>
+          <a:ln/>
+        </p:spPr>
+        <p:txBody>
+          <a:bodyPr wrap="square" rtlCol="0" anchor="ctr"/>
+          <a:lstStyle/>
+          <a:p>
+            <a:pPr algn="r" indent="0" marL="0">
+              <a:buNone/>
+            </a:pPr>
+            <a:r>
+              <a:rPr lang="en-US" sz="1100" dirty="0">
+                <a:solidFill>
+                  <a:srgbClr val="4B5563"/>
+                </a:solidFill>
+                <a:latin typeface="Calibri" pitchFamily="34" charset="0"/>
+                <a:ea typeface="Calibri" pitchFamily="34" charset="-122"/>
+                <a:cs typeface="Calibri" pitchFamily="34" charset="-120"/>
+              </a:rPr>
+              <a:t>18</a:t>
             </a:r>
             <a:endParaRPr lang="en-US" sz="1100" dirty="0"/>
           </a:p>

</xml_diff>